<commit_message>
docs(slides): replace limitations with additional features slide
Co-Authored-By: Claude Sonnet 4.6 <noreply@anthropic.com>
</commit_message>
<xml_diff>
--- a/DocRAG.pptx
+++ b/DocRAG.pptx
@@ -3405,7 +3405,7 @@
                   <a:srgbClr val="3FB950"/>
                 </a:solidFill>
               </a:rPr>
-              <a:t>pgvector</a:t>
+              <a:t>pgvector + BM25</a:t>
             </a:r>
           </a:p>
         </p:txBody>
@@ -3563,7 +3563,7 @@
                   <a:srgbClr val="F78166"/>
                 </a:solidFill>
               </a:rPr>
-              <a:t>Auto-scaled RAG</a:t>
+              <a:t>Hybrid RAG</a:t>
             </a:r>
           </a:p>
         </p:txBody>
@@ -3592,7 +3592,7 @@
           <a:p>
             <a:pPr algn="l"/>
             <a:r>
-              <a:rPr sz="1300" b="0" i="0">
+              <a:rPr sz="1200" b="0" i="0">
                 <a:solidFill>
                   <a:srgbClr val="E6EDF3"/>
                 </a:solidFill>
@@ -3610,7 +3610,7 @@
         </p:nvSpPr>
         <p:spPr>
           <a:xfrm>
-            <a:off x="7498079" y="2148840"/>
+            <a:off x="7498079" y="2121408"/>
             <a:ext cx="4297680" cy="365760"/>
           </a:xfrm>
           <a:prstGeom prst="rect">
@@ -3626,12 +3626,12 @@
           <a:p>
             <a:pPr algn="l"/>
             <a:r>
-              <a:rPr sz="1300" b="0" i="0">
+              <a:rPr sz="1200" b="0" i="0">
                 <a:solidFill>
                   <a:srgbClr val="E6EDF3"/>
                 </a:solidFill>
               </a:rPr>
-              <a:t>✂️  Auto-scaled chunking</a:t>
+              <a:t>✂️  Auto-scaled chunking + parent context</a:t>
             </a:r>
           </a:p>
         </p:txBody>
@@ -3644,7 +3644,7 @@
         </p:nvSpPr>
         <p:spPr>
           <a:xfrm>
-            <a:off x="7498079" y="2651760"/>
+            <a:off x="7498079" y="2596896"/>
             <a:ext cx="4297680" cy="365760"/>
           </a:xfrm>
           <a:prstGeom prst="rect">
@@ -3660,7 +3660,7 @@
           <a:p>
             <a:pPr algn="l"/>
             <a:r>
-              <a:rPr sz="1300" b="0" i="0">
+              <a:rPr sz="1200" b="0" i="0">
                 <a:solidFill>
                   <a:srgbClr val="E6EDF3"/>
                 </a:solidFill>
@@ -3678,7 +3678,7 @@
         </p:nvSpPr>
         <p:spPr>
           <a:xfrm>
-            <a:off x="7498079" y="3154680"/>
+            <a:off x="7498079" y="3072384"/>
             <a:ext cx="4297680" cy="365760"/>
           </a:xfrm>
           <a:prstGeom prst="rect">
@@ -3694,12 +3694,12 @@
           <a:p>
             <a:pPr algn="l"/>
             <a:r>
-              <a:rPr sz="1300" b="0" i="0">
+              <a:rPr sz="1200" b="0" i="0">
                 <a:solidFill>
                   <a:srgbClr val="E6EDF3"/>
                 </a:solidFill>
               </a:rPr>
-              <a:t>🔍  pgvector top-k search</a:t>
+              <a:t>🔍  Hybrid BM25 + vector search (RRF)</a:t>
             </a:r>
           </a:p>
         </p:txBody>
@@ -3712,7 +3712,7 @@
         </p:nvSpPr>
         <p:spPr>
           <a:xfrm>
-            <a:off x="7498079" y="3657600"/>
+            <a:off x="7498079" y="3547872"/>
             <a:ext cx="4297680" cy="365760"/>
           </a:xfrm>
           <a:prstGeom prst="rect">
@@ -3728,11 +3728,45 @@
           <a:p>
             <a:pPr algn="l"/>
             <a:r>
-              <a:rPr sz="1300" b="0" i="0">
+              <a:rPr sz="1200" b="0" i="0">
                 <a:solidFill>
                   <a:srgbClr val="E6EDF3"/>
                 </a:solidFill>
               </a:rPr>
+              <a:t>🔃  Gemini re-ranking</a:t>
+            </a:r>
+          </a:p>
+        </p:txBody>
+      </p:sp>
+      <p:sp>
+        <p:nvSpPr>
+          <p:cNvPr id="19" name="TextBox 18"/>
+          <p:cNvSpPr txBox="1"/>
+          <p:nvPr/>
+        </p:nvSpPr>
+        <p:spPr>
+          <a:xfrm>
+            <a:off x="7498079" y="4023360"/>
+            <a:ext cx="4297680" cy="365760"/>
+          </a:xfrm>
+          <a:prstGeom prst="rect">
+            <a:avLst/>
+          </a:prstGeom>
+          <a:noFill/>
+        </p:spPr>
+        <p:txBody>
+          <a:bodyPr wrap="square">
+            <a:spAutoFit/>
+          </a:bodyPr>
+          <a:lstStyle/>
+          <a:p>
+            <a:pPr algn="l"/>
+            <a:r>
+              <a:rPr sz="1200" b="0" i="0">
+                <a:solidFill>
+                  <a:srgbClr val="E6EDF3"/>
+                </a:solidFill>
+              </a:rPr>
               <a:t>💬  Grounded streaming answer</a:t>
             </a:r>
           </a:p>
@@ -3740,13 +3774,13 @@
       </p:sp>
       <p:sp>
         <p:nvSpPr>
-          <p:cNvPr id="19" name="TextBox 18"/>
-          <p:cNvSpPr txBox="1"/>
-          <p:nvPr/>
-        </p:nvSpPr>
-        <p:spPr>
-          <a:xfrm>
-            <a:off x="7498079" y="4160520"/>
+          <p:cNvPr id="20" name="TextBox 19"/>
+          <p:cNvSpPr txBox="1"/>
+          <p:nvPr/>
+        </p:nvSpPr>
+        <p:spPr>
+          <a:xfrm>
+            <a:off x="7498079" y="4498848"/>
             <a:ext cx="4297680" cy="365760"/>
           </a:xfrm>
           <a:prstGeom prst="rect">
@@ -3762,12 +3796,12 @@
           <a:p>
             <a:pPr algn="l"/>
             <a:r>
-              <a:rPr sz="1300" b="0" i="0">
+              <a:rPr sz="1200" b="0" i="0">
                 <a:solidFill>
                   <a:srgbClr val="E6EDF3"/>
                 </a:solidFill>
               </a:rPr>
-              <a:t>📎  [Chunk N] inline citations</a:t>
+              <a:t>📎  [Chunk N] citations with similarity %</a:t>
             </a:r>
           </a:p>
         </p:txBody>
@@ -3827,7 +3861,7 @@
                   <a:srgbClr val="58A6FF"/>
                 </a:solidFill>
               </a:rPr>
-              <a:t>HONEST ASSESSMENT</a:t>
+              <a:t>DEMONSTRATION</a:t>
             </a:r>
           </a:p>
         </p:txBody>
@@ -3861,7 +3895,7 @@
                   <a:srgbClr val="E6EDF3"/>
                 </a:solidFill>
               </a:rPr>
-              <a:t>Limitations</a:t>
+              <a:t>Live demo</a:t>
             </a:r>
           </a:p>
         </p:txBody>
@@ -3881,7 +3915,7 @@
             <a:avLst/>
           </a:prstGeom>
           <a:solidFill>
-            <a:srgbClr val="F78166"/>
+            <a:srgbClr val="3FB950"/>
           </a:solidFill>
           <a:ln>
             <a:noFill/>
@@ -3917,18 +3951,18 @@
         </p:nvSpPr>
         <p:spPr>
           <a:xfrm>
-            <a:off x="274320" y="1463040"/>
-            <a:ext cx="3657600" cy="1920240"/>
+            <a:off x="548640" y="1463040"/>
+            <a:ext cx="11091672" cy="4114800"/>
           </a:xfrm>
           <a:prstGeom prst="rect">
             <a:avLst/>
           </a:prstGeom>
           <a:solidFill>
-            <a:srgbClr val="161B22"/>
+            <a:srgbClr val="0F1B2D"/>
           </a:solidFill>
           <a:ln w="9525">
             <a:solidFill>
-              <a:srgbClr val="30363D"/>
+              <a:srgbClr val="58A6FF"/>
             </a:solidFill>
           </a:ln>
         </p:spPr>
@@ -3956,44 +3990,35 @@
       </p:sp>
       <p:sp>
         <p:nvSpPr>
-          <p:cNvPr id="6" name="Rectangle 5"/>
-          <p:cNvSpPr/>
-          <p:nvPr/>
-        </p:nvSpPr>
-        <p:spPr>
-          <a:xfrm>
-            <a:off x="274320" y="1463040"/>
-            <a:ext cx="3657600" cy="38100"/>
-          </a:xfrm>
-          <a:prstGeom prst="rect">
-            <a:avLst/>
-          </a:prstGeom>
-          <a:solidFill>
-            <a:srgbClr val="F78166"/>
-          </a:solidFill>
-          <a:ln>
-            <a:noFill/>
-          </a:ln>
-        </p:spPr>
-        <p:style>
-          <a:lnRef idx="1">
-            <a:schemeClr val="accent1"/>
-          </a:lnRef>
-          <a:fillRef idx="3">
-            <a:schemeClr val="accent1"/>
-          </a:fillRef>
-          <a:effectRef idx="2">
-            <a:schemeClr val="accent1"/>
-          </a:effectRef>
-          <a:fontRef idx="minor">
-            <a:schemeClr val="lt1"/>
-          </a:fontRef>
-        </p:style>
-        <p:txBody>
-          <a:bodyPr rtlCol="0" anchor="ctr"/>
-          <a:lstStyle/>
-          <a:p>
-            <a:pPr algn="ctr"/>
+          <p:cNvPr id="6" name="TextBox 5"/>
+          <p:cNvSpPr txBox="1"/>
+          <p:nvPr/>
+        </p:nvSpPr>
+        <p:spPr>
+          <a:xfrm>
+            <a:off x="822960" y="1645920"/>
+            <a:ext cx="10515600" cy="365760"/>
+          </a:xfrm>
+          <a:prstGeom prst="rect">
+            <a:avLst/>
+          </a:prstGeom>
+          <a:noFill/>
+        </p:spPr>
+        <p:txBody>
+          <a:bodyPr wrap="square">
+            <a:spAutoFit/>
+          </a:bodyPr>
+          <a:lstStyle/>
+          <a:p>
+            <a:pPr algn="l"/>
+            <a:r>
+              <a:rPr sz="1400" b="1" i="0">
+                <a:solidFill>
+                  <a:srgbClr val="E6EDF3"/>
+                </a:solidFill>
+              </a:rPr>
+              <a:t>Demo flow</a:t>
+            </a:r>
           </a:p>
         </p:txBody>
       </p:sp>
@@ -4005,8 +4030,8 @@
         </p:nvSpPr>
         <p:spPr>
           <a:xfrm>
-            <a:off x="411480" y="1600200"/>
-            <a:ext cx="3383280" cy="365760"/>
+            <a:off x="822960" y="2103120"/>
+            <a:ext cx="457200" cy="502920"/>
           </a:xfrm>
           <a:prstGeom prst="rect">
             <a:avLst/>
@@ -4021,12 +4046,12 @@
           <a:p>
             <a:pPr algn="l"/>
             <a:r>
-              <a:rPr sz="1200" b="1" i="0">
+              <a:rPr sz="1800" b="0" i="0">
                 <a:solidFill>
                   <a:srgbClr val="E6EDF3"/>
                 </a:solidFill>
               </a:rPr>
-              <a:t>⚠️  Single document only</a:t>
+              <a:t>1️⃣</a:t>
             </a:r>
           </a:p>
         </p:txBody>
@@ -4039,8 +4064,8 @@
         </p:nvSpPr>
         <p:spPr>
           <a:xfrm>
-            <a:off x="411480" y="1993392"/>
-            <a:ext cx="3383280" cy="1188720"/>
+            <a:off x="1371600" y="2148840"/>
+            <a:ext cx="10058400" cy="320040"/>
           </a:xfrm>
           <a:prstGeom prst="rect">
             <a:avLst/>
@@ -4055,101 +4080,81 @@
           <a:p>
             <a:pPr algn="l"/>
             <a:r>
+              <a:rPr sz="1300" b="1" i="0">
+                <a:solidFill>
+                  <a:srgbClr val="E6EDF3"/>
+                </a:solidFill>
+              </a:rPr>
+              <a:t>Upload a PDF</a:t>
+            </a:r>
+          </a:p>
+        </p:txBody>
+      </p:sp>
+      <p:sp>
+        <p:nvSpPr>
+          <p:cNvPr id="9" name="TextBox 8"/>
+          <p:cNvSpPr txBox="1"/>
+          <p:nvPr/>
+        </p:nvSpPr>
+        <p:spPr>
+          <a:xfrm>
+            <a:off x="1371600" y="2450592"/>
+            <a:ext cx="10058400" cy="320040"/>
+          </a:xfrm>
+          <a:prstGeom prst="rect">
+            <a:avLst/>
+          </a:prstGeom>
+          <a:noFill/>
+        </p:spPr>
+        <p:txBody>
+          <a:bodyPr wrap="square">
+            <a:spAutoFit/>
+          </a:bodyPr>
+          <a:lstStyle/>
+          <a:p>
+            <a:pPr algn="l"/>
+            <a:r>
               <a:rPr sz="1100" b="0" i="0">
                 <a:solidFill>
                   <a:srgbClr val="8B949E"/>
                 </a:solidFill>
               </a:rPr>
-              <a:t>Uploading a new PDF clears the previous one. No multi-doc library or comparison queries.</a:t>
-            </a:r>
-          </a:p>
-        </p:txBody>
-      </p:sp>
-      <p:sp>
-        <p:nvSpPr>
-          <p:cNvPr id="9" name="Rectangle 8"/>
-          <p:cNvSpPr/>
-          <p:nvPr/>
-        </p:nvSpPr>
-        <p:spPr>
-          <a:xfrm>
-            <a:off x="4160520" y="1463040"/>
-            <a:ext cx="3657600" cy="1920240"/>
-          </a:xfrm>
-          <a:prstGeom prst="rect">
-            <a:avLst/>
-          </a:prstGeom>
-          <a:solidFill>
-            <a:srgbClr val="161B22"/>
-          </a:solidFill>
-          <a:ln w="9525">
-            <a:solidFill>
-              <a:srgbClr val="30363D"/>
-            </a:solidFill>
-          </a:ln>
-        </p:spPr>
-        <p:style>
-          <a:lnRef idx="1">
-            <a:schemeClr val="accent1"/>
-          </a:lnRef>
-          <a:fillRef idx="3">
-            <a:schemeClr val="accent1"/>
-          </a:fillRef>
-          <a:effectRef idx="2">
-            <a:schemeClr val="accent1"/>
-          </a:effectRef>
-          <a:fontRef idx="minor">
-            <a:schemeClr val="lt1"/>
-          </a:fontRef>
-        </p:style>
-        <p:txBody>
-          <a:bodyPr rtlCol="0" anchor="ctr"/>
-          <a:lstStyle/>
-          <a:p>
-            <a:pPr algn="ctr"/>
-          </a:p>
-        </p:txBody>
-      </p:sp>
-      <p:sp>
-        <p:nvSpPr>
-          <p:cNvPr id="10" name="Rectangle 9"/>
-          <p:cNvSpPr/>
-          <p:nvPr/>
-        </p:nvSpPr>
-        <p:spPr>
-          <a:xfrm>
-            <a:off x="4160520" y="1463040"/>
-            <a:ext cx="3657600" cy="38100"/>
-          </a:xfrm>
-          <a:prstGeom prst="rect">
-            <a:avLst/>
-          </a:prstGeom>
-          <a:solidFill>
-            <a:srgbClr val="F78166"/>
-          </a:solidFill>
-          <a:ln>
-            <a:noFill/>
-          </a:ln>
-        </p:spPr>
-        <p:style>
-          <a:lnRef idx="1">
-            <a:schemeClr val="accent1"/>
-          </a:lnRef>
-          <a:fillRef idx="3">
-            <a:schemeClr val="accent1"/>
-          </a:fillRef>
-          <a:effectRef idx="2">
-            <a:schemeClr val="accent1"/>
-          </a:effectRef>
-          <a:fontRef idx="minor">
-            <a:schemeClr val="lt1"/>
-          </a:fontRef>
-        </p:style>
-        <p:txBody>
-          <a:bodyPr rtlCol="0" anchor="ctr"/>
-          <a:lstStyle/>
-          <a:p>
-            <a:pPr algn="ctr"/>
+              <a:t>Drag &amp; drop — watch ingest progress: extract → chunk → embed → done</a:t>
+            </a:r>
+          </a:p>
+        </p:txBody>
+      </p:sp>
+      <p:sp>
+        <p:nvSpPr>
+          <p:cNvPr id="10" name="TextBox 9"/>
+          <p:cNvSpPr txBox="1"/>
+          <p:nvPr/>
+        </p:nvSpPr>
+        <p:spPr>
+          <a:xfrm>
+            <a:off x="822960" y="2880360"/>
+            <a:ext cx="457200" cy="502920"/>
+          </a:xfrm>
+          <a:prstGeom prst="rect">
+            <a:avLst/>
+          </a:prstGeom>
+          <a:noFill/>
+        </p:spPr>
+        <p:txBody>
+          <a:bodyPr wrap="square">
+            <a:spAutoFit/>
+          </a:bodyPr>
+          <a:lstStyle/>
+          <a:p>
+            <a:pPr algn="l"/>
+            <a:r>
+              <a:rPr sz="1800" b="0" i="0">
+                <a:solidFill>
+                  <a:srgbClr val="E6EDF3"/>
+                </a:solidFill>
+              </a:rPr>
+              <a:t>2️⃣</a:t>
+            </a:r>
           </a:p>
         </p:txBody>
       </p:sp>
@@ -4161,8 +4166,8 @@
         </p:nvSpPr>
         <p:spPr>
           <a:xfrm>
-            <a:off x="4297680" y="1600200"/>
-            <a:ext cx="3383280" cy="365760"/>
+            <a:off x="1371600" y="2926080"/>
+            <a:ext cx="10058400" cy="320040"/>
           </a:xfrm>
           <a:prstGeom prst="rect">
             <a:avLst/>
@@ -4177,12 +4182,12 @@
           <a:p>
             <a:pPr algn="l"/>
             <a:r>
-              <a:rPr sz="1200" b="1" i="0">
+              <a:rPr sz="1300" b="1" i="0">
                 <a:solidFill>
                   <a:srgbClr val="E6EDF3"/>
                 </a:solidFill>
               </a:rPr>
-              <a:t>⚠️  Dense retrieval only</a:t>
+              <a:t>Ask a specific question</a:t>
             </a:r>
           </a:p>
         </p:txBody>
@@ -4195,8 +4200,8 @@
         </p:nvSpPr>
         <p:spPr>
           <a:xfrm>
-            <a:off x="4297680" y="1993392"/>
-            <a:ext cx="3383280" cy="1188720"/>
+            <a:off x="1371600" y="3227832"/>
+            <a:ext cx="10058400" cy="320040"/>
           </a:xfrm>
           <a:prstGeom prst="rect">
             <a:avLst/>
@@ -4216,96 +4221,76 @@
                   <a:srgbClr val="8B949E"/>
                 </a:solidFill>
               </a:rPr>
-              <a:t>No BM25/full-text search. Exact keyword queries (model names, IDs) can miss relevant chunks.</a:t>
-            </a:r>
-          </a:p>
-        </p:txBody>
-      </p:sp>
-      <p:sp>
-        <p:nvSpPr>
-          <p:cNvPr id="13" name="Rectangle 12"/>
-          <p:cNvSpPr/>
-          <p:nvPr/>
-        </p:nvSpPr>
-        <p:spPr>
-          <a:xfrm>
-            <a:off x="8046720" y="1463040"/>
-            <a:ext cx="3657600" cy="1920240"/>
-          </a:xfrm>
-          <a:prstGeom prst="rect">
-            <a:avLst/>
-          </a:prstGeom>
-          <a:solidFill>
-            <a:srgbClr val="161B22"/>
-          </a:solidFill>
-          <a:ln w="9525">
-            <a:solidFill>
-              <a:srgbClr val="30363D"/>
-            </a:solidFill>
-          </a:ln>
-        </p:spPr>
-        <p:style>
-          <a:lnRef idx="1">
-            <a:schemeClr val="accent1"/>
-          </a:lnRef>
-          <a:fillRef idx="3">
-            <a:schemeClr val="accent1"/>
-          </a:fillRef>
-          <a:effectRef idx="2">
-            <a:schemeClr val="accent1"/>
-          </a:effectRef>
-          <a:fontRef idx="minor">
-            <a:schemeClr val="lt1"/>
-          </a:fontRef>
-        </p:style>
-        <p:txBody>
-          <a:bodyPr rtlCol="0" anchor="ctr"/>
-          <a:lstStyle/>
-          <a:p>
-            <a:pPr algn="ctr"/>
-          </a:p>
-        </p:txBody>
-      </p:sp>
-      <p:sp>
-        <p:nvSpPr>
-          <p:cNvPr id="14" name="Rectangle 13"/>
-          <p:cNvSpPr/>
-          <p:nvPr/>
-        </p:nvSpPr>
-        <p:spPr>
-          <a:xfrm>
-            <a:off x="8046720" y="1463040"/>
-            <a:ext cx="3657600" cy="38100"/>
-          </a:xfrm>
-          <a:prstGeom prst="rect">
-            <a:avLst/>
-          </a:prstGeom>
-          <a:solidFill>
-            <a:srgbClr val="F78166"/>
-          </a:solidFill>
-          <a:ln>
-            <a:noFill/>
-          </a:ln>
-        </p:spPr>
-        <p:style>
-          <a:lnRef idx="1">
-            <a:schemeClr val="accent1"/>
-          </a:lnRef>
-          <a:fillRef idx="3">
-            <a:schemeClr val="accent1"/>
-          </a:fillRef>
-          <a:effectRef idx="2">
-            <a:schemeClr val="accent1"/>
-          </a:effectRef>
-          <a:fontRef idx="minor">
-            <a:schemeClr val="lt1"/>
-          </a:fontRef>
-        </p:style>
-        <p:txBody>
-          <a:bodyPr rtlCol="0" anchor="ctr"/>
-          <a:lstStyle/>
-          <a:p>
-            <a:pPr algn="ctr"/>
+              <a:t>Observe streamed response, citation pills with similarity % badges, and hover for raw chunk text</a:t>
+            </a:r>
+          </a:p>
+        </p:txBody>
+      </p:sp>
+      <p:sp>
+        <p:nvSpPr>
+          <p:cNvPr id="13" name="TextBox 12"/>
+          <p:cNvSpPr txBox="1"/>
+          <p:nvPr/>
+        </p:nvSpPr>
+        <p:spPr>
+          <a:xfrm>
+            <a:off x="822960" y="3657600"/>
+            <a:ext cx="457200" cy="502920"/>
+          </a:xfrm>
+          <a:prstGeom prst="rect">
+            <a:avLst/>
+          </a:prstGeom>
+          <a:noFill/>
+        </p:spPr>
+        <p:txBody>
+          <a:bodyPr wrap="square">
+            <a:spAutoFit/>
+          </a:bodyPr>
+          <a:lstStyle/>
+          <a:p>
+            <a:pPr algn="l"/>
+            <a:r>
+              <a:rPr sz="1800" b="0" i="0">
+                <a:solidFill>
+                  <a:srgbClr val="E6EDF3"/>
+                </a:solidFill>
+              </a:rPr>
+              <a:t>3️⃣</a:t>
+            </a:r>
+          </a:p>
+        </p:txBody>
+      </p:sp>
+      <p:sp>
+        <p:nvSpPr>
+          <p:cNvPr id="14" name="TextBox 13"/>
+          <p:cNvSpPr txBox="1"/>
+          <p:nvPr/>
+        </p:nvSpPr>
+        <p:spPr>
+          <a:xfrm>
+            <a:off x="1371600" y="3703320"/>
+            <a:ext cx="10058400" cy="320040"/>
+          </a:xfrm>
+          <a:prstGeom prst="rect">
+            <a:avLst/>
+          </a:prstGeom>
+          <a:noFill/>
+        </p:spPr>
+        <p:txBody>
+          <a:bodyPr wrap="square">
+            <a:spAutoFit/>
+          </a:bodyPr>
+          <a:lstStyle/>
+          <a:p>
+            <a:pPr algn="l"/>
+            <a:r>
+              <a:rPr sz="1300" b="1" i="0">
+                <a:solidFill>
+                  <a:srgbClr val="E6EDF3"/>
+                </a:solidFill>
+              </a:rPr>
+              <a:t>Re-upload the same PDF</a:t>
+            </a:r>
           </a:p>
         </p:txBody>
       </p:sp>
@@ -4317,8 +4302,8 @@
         </p:nvSpPr>
         <p:spPr>
           <a:xfrm>
-            <a:off x="8183880" y="1600200"/>
-            <a:ext cx="3383280" cy="365760"/>
+            <a:off x="1371600" y="4005072"/>
+            <a:ext cx="10058400" cy="320040"/>
           </a:xfrm>
           <a:prstGeom prst="rect">
             <a:avLst/>
@@ -4333,26 +4318,60 @@
           <a:p>
             <a:pPr algn="l"/>
             <a:r>
-              <a:rPr sz="1200" b="1" i="0">
+              <a:rPr sz="1100" b="0" i="0">
+                <a:solidFill>
+                  <a:srgbClr val="8B949E"/>
+                </a:solidFill>
+              </a:rPr>
+              <a:t>Ingest completes instantly — duplicate detection skips all embedding</a:t>
+            </a:r>
+          </a:p>
+        </p:txBody>
+      </p:sp>
+      <p:sp>
+        <p:nvSpPr>
+          <p:cNvPr id="16" name="TextBox 15"/>
+          <p:cNvSpPr txBox="1"/>
+          <p:nvPr/>
+        </p:nvSpPr>
+        <p:spPr>
+          <a:xfrm>
+            <a:off x="822960" y="4434840"/>
+            <a:ext cx="457200" cy="502920"/>
+          </a:xfrm>
+          <a:prstGeom prst="rect">
+            <a:avLst/>
+          </a:prstGeom>
+          <a:noFill/>
+        </p:spPr>
+        <p:txBody>
+          <a:bodyPr wrap="square">
+            <a:spAutoFit/>
+          </a:bodyPr>
+          <a:lstStyle/>
+          <a:p>
+            <a:pPr algn="l"/>
+            <a:r>
+              <a:rPr sz="1800" b="0" i="0">
                 <a:solidFill>
                   <a:srgbClr val="E6EDF3"/>
                 </a:solidFill>
               </a:rPr>
-              <a:t>⚠️  No re-ranking</a:t>
-            </a:r>
-          </a:p>
-        </p:txBody>
-      </p:sp>
-      <p:sp>
-        <p:nvSpPr>
-          <p:cNvPr id="16" name="TextBox 15"/>
-          <p:cNvSpPr txBox="1"/>
-          <p:nvPr/>
-        </p:nvSpPr>
-        <p:spPr>
-          <a:xfrm>
-            <a:off x="8183880" y="1993392"/>
-            <a:ext cx="3383280" cy="1188720"/>
+              <a:t>4️⃣</a:t>
+            </a:r>
+          </a:p>
+        </p:txBody>
+      </p:sp>
+      <p:sp>
+        <p:nvSpPr>
+          <p:cNvPr id="17" name="TextBox 16"/>
+          <p:cNvSpPr txBox="1"/>
+          <p:nvPr/>
+        </p:nvSpPr>
+        <p:spPr>
+          <a:xfrm>
+            <a:off x="1371600" y="4480560"/>
+            <a:ext cx="10058400" cy="320040"/>
           </a:xfrm>
           <a:prstGeom prst="rect">
             <a:avLst/>
@@ -4367,101 +4386,47 @@
           <a:p>
             <a:pPr algn="l"/>
             <a:r>
+              <a:rPr sz="1300" b="1" i="0">
+                <a:solidFill>
+                  <a:srgbClr val="E6EDF3"/>
+                </a:solidFill>
+              </a:rPr>
+              <a:t>Ask something unanswerable</a:t>
+            </a:r>
+          </a:p>
+        </p:txBody>
+      </p:sp>
+      <p:sp>
+        <p:nvSpPr>
+          <p:cNvPr id="18" name="TextBox 17"/>
+          <p:cNvSpPr txBox="1"/>
+          <p:nvPr/>
+        </p:nvSpPr>
+        <p:spPr>
+          <a:xfrm>
+            <a:off x="1371600" y="4782312"/>
+            <a:ext cx="10058400" cy="320040"/>
+          </a:xfrm>
+          <a:prstGeom prst="rect">
+            <a:avLst/>
+          </a:prstGeom>
+          <a:noFill/>
+        </p:spPr>
+        <p:txBody>
+          <a:bodyPr wrap="square">
+            <a:spAutoFit/>
+          </a:bodyPr>
+          <a:lstStyle/>
+          <a:p>
+            <a:pPr algn="l"/>
+            <a:r>
               <a:rPr sz="1100" b="0" i="0">
                 <a:solidFill>
                   <a:srgbClr val="8B949E"/>
                 </a:solidFill>
               </a:rPr>
-              <a:t>Top-k chunks passed to the LLM as-is. Semantically-close-but-irrelevant chunks aren't filtered.</a:t>
-            </a:r>
-          </a:p>
-        </p:txBody>
-      </p:sp>
-      <p:sp>
-        <p:nvSpPr>
-          <p:cNvPr id="17" name="Rectangle 16"/>
-          <p:cNvSpPr/>
-          <p:nvPr/>
-        </p:nvSpPr>
-        <p:spPr>
-          <a:xfrm>
-            <a:off x="274320" y="3657600"/>
-            <a:ext cx="3657600" cy="1920240"/>
-          </a:xfrm>
-          <a:prstGeom prst="rect">
-            <a:avLst/>
-          </a:prstGeom>
-          <a:solidFill>
-            <a:srgbClr val="161B22"/>
-          </a:solidFill>
-          <a:ln w="9525">
-            <a:solidFill>
-              <a:srgbClr val="30363D"/>
-            </a:solidFill>
-          </a:ln>
-        </p:spPr>
-        <p:style>
-          <a:lnRef idx="1">
-            <a:schemeClr val="accent1"/>
-          </a:lnRef>
-          <a:fillRef idx="3">
-            <a:schemeClr val="accent1"/>
-          </a:fillRef>
-          <a:effectRef idx="2">
-            <a:schemeClr val="accent1"/>
-          </a:effectRef>
-          <a:fontRef idx="minor">
-            <a:schemeClr val="lt1"/>
-          </a:fontRef>
-        </p:style>
-        <p:txBody>
-          <a:bodyPr rtlCol="0" anchor="ctr"/>
-          <a:lstStyle/>
-          <a:p>
-            <a:pPr algn="ctr"/>
-          </a:p>
-        </p:txBody>
-      </p:sp>
-      <p:sp>
-        <p:nvSpPr>
-          <p:cNvPr id="18" name="Rectangle 17"/>
-          <p:cNvSpPr/>
-          <p:nvPr/>
-        </p:nvSpPr>
-        <p:spPr>
-          <a:xfrm>
-            <a:off x="274320" y="3657600"/>
-            <a:ext cx="3657600" cy="38100"/>
-          </a:xfrm>
-          <a:prstGeom prst="rect">
-            <a:avLst/>
-          </a:prstGeom>
-          <a:solidFill>
-            <a:srgbClr val="F78166"/>
-          </a:solidFill>
-          <a:ln>
-            <a:noFill/>
-          </a:ln>
-        </p:spPr>
-        <p:style>
-          <a:lnRef idx="1">
-            <a:schemeClr val="accent1"/>
-          </a:lnRef>
-          <a:fillRef idx="3">
-            <a:schemeClr val="accent1"/>
-          </a:fillRef>
-          <a:effectRef idx="2">
-            <a:schemeClr val="accent1"/>
-          </a:effectRef>
-          <a:fontRef idx="minor">
-            <a:schemeClr val="lt1"/>
-          </a:fontRef>
-        </p:style>
-        <p:txBody>
-          <a:bodyPr rtlCol="0" anchor="ctr"/>
-          <a:lstStyle/>
-          <a:p>
-            <a:pPr algn="ctr"/>
+              <a:t>System responds "I don't know." — no hallucination</a:t>
+            </a:r>
           </a:p>
         </p:txBody>
       </p:sp>
@@ -4473,374 +4438,28 @@
         </p:nvSpPr>
         <p:spPr>
           <a:xfrm>
-            <a:off x="411480" y="3794760"/>
-            <a:ext cx="3383280" cy="365760"/>
-          </a:xfrm>
-          <a:prstGeom prst="rect">
-            <a:avLst/>
-          </a:prstGeom>
-          <a:noFill/>
-        </p:spPr>
-        <p:txBody>
-          <a:bodyPr wrap="square">
-            <a:spAutoFit/>
-          </a:bodyPr>
-          <a:lstStyle/>
-          <a:p>
-            <a:pPr algn="l"/>
-            <a:r>
-              <a:rPr sz="1200" b="1" i="0">
-                <a:solidFill>
-                  <a:srgbClr val="E6EDF3"/>
-                </a:solidFill>
-              </a:rPr>
-              <a:t>⚠️  No duplicate detection</a:t>
-            </a:r>
-          </a:p>
-        </p:txBody>
-      </p:sp>
-      <p:sp>
-        <p:nvSpPr>
-          <p:cNvPr id="20" name="TextBox 19"/>
-          <p:cNvSpPr txBox="1"/>
-          <p:nvPr/>
-        </p:nvSpPr>
-        <p:spPr>
-          <a:xfrm>
-            <a:off x="411480" y="4187952"/>
-            <a:ext cx="3383280" cy="1188720"/>
-          </a:xfrm>
-          <a:prstGeom prst="rect">
-            <a:avLst/>
-          </a:prstGeom>
-          <a:noFill/>
-        </p:spPr>
-        <p:txBody>
-          <a:bodyPr wrap="square">
-            <a:spAutoFit/>
-          </a:bodyPr>
-          <a:lstStyle/>
-          <a:p>
-            <a:pPr algn="l"/>
+            <a:off x="548640" y="5760720"/>
+            <a:ext cx="11091672" cy="365760"/>
+          </a:xfrm>
+          <a:prstGeom prst="rect">
+            <a:avLst/>
+          </a:prstGeom>
+          <a:noFill/>
+        </p:spPr>
+        <p:txBody>
+          <a:bodyPr wrap="square">
+            <a:spAutoFit/>
+          </a:bodyPr>
+          <a:lstStyle/>
+          <a:p>
+            <a:pPr algn="ctr"/>
             <a:r>
               <a:rPr sz="1100" b="0" i="0">
                 <a:solidFill>
                   <a:srgbClr val="8B949E"/>
                 </a:solidFill>
               </a:rPr>
-              <a:t>Re-uploading the same PDF re-embeds everything even though the doc_id (SHA-256) is identical.</a:t>
-            </a:r>
-          </a:p>
-        </p:txBody>
-      </p:sp>
-      <p:sp>
-        <p:nvSpPr>
-          <p:cNvPr id="21" name="Rectangle 20"/>
-          <p:cNvSpPr/>
-          <p:nvPr/>
-        </p:nvSpPr>
-        <p:spPr>
-          <a:xfrm>
-            <a:off x="4160520" y="3657600"/>
-            <a:ext cx="3657600" cy="1920240"/>
-          </a:xfrm>
-          <a:prstGeom prst="rect">
-            <a:avLst/>
-          </a:prstGeom>
-          <a:solidFill>
-            <a:srgbClr val="161B22"/>
-          </a:solidFill>
-          <a:ln w="9525">
-            <a:solidFill>
-              <a:srgbClr val="30363D"/>
-            </a:solidFill>
-          </a:ln>
-        </p:spPr>
-        <p:style>
-          <a:lnRef idx="1">
-            <a:schemeClr val="accent1"/>
-          </a:lnRef>
-          <a:fillRef idx="3">
-            <a:schemeClr val="accent1"/>
-          </a:fillRef>
-          <a:effectRef idx="2">
-            <a:schemeClr val="accent1"/>
-          </a:effectRef>
-          <a:fontRef idx="minor">
-            <a:schemeClr val="lt1"/>
-          </a:fontRef>
-        </p:style>
-        <p:txBody>
-          <a:bodyPr rtlCol="0" anchor="ctr"/>
-          <a:lstStyle/>
-          <a:p>
-            <a:pPr algn="ctr"/>
-          </a:p>
-        </p:txBody>
-      </p:sp>
-      <p:sp>
-        <p:nvSpPr>
-          <p:cNvPr id="22" name="Rectangle 21"/>
-          <p:cNvSpPr/>
-          <p:nvPr/>
-        </p:nvSpPr>
-        <p:spPr>
-          <a:xfrm>
-            <a:off x="4160520" y="3657600"/>
-            <a:ext cx="3657600" cy="38100"/>
-          </a:xfrm>
-          <a:prstGeom prst="rect">
-            <a:avLst/>
-          </a:prstGeom>
-          <a:solidFill>
-            <a:srgbClr val="F78166"/>
-          </a:solidFill>
-          <a:ln>
-            <a:noFill/>
-          </a:ln>
-        </p:spPr>
-        <p:style>
-          <a:lnRef idx="1">
-            <a:schemeClr val="accent1"/>
-          </a:lnRef>
-          <a:fillRef idx="3">
-            <a:schemeClr val="accent1"/>
-          </a:fillRef>
-          <a:effectRef idx="2">
-            <a:schemeClr val="accent1"/>
-          </a:effectRef>
-          <a:fontRef idx="minor">
-            <a:schemeClr val="lt1"/>
-          </a:fontRef>
-        </p:style>
-        <p:txBody>
-          <a:bodyPr rtlCol="0" anchor="ctr"/>
-          <a:lstStyle/>
-          <a:p>
-            <a:pPr algn="ctr"/>
-          </a:p>
-        </p:txBody>
-      </p:sp>
-      <p:sp>
-        <p:nvSpPr>
-          <p:cNvPr id="23" name="TextBox 22"/>
-          <p:cNvSpPr txBox="1"/>
-          <p:nvPr/>
-        </p:nvSpPr>
-        <p:spPr>
-          <a:xfrm>
-            <a:off x="4297680" y="3794760"/>
-            <a:ext cx="3383280" cy="365760"/>
-          </a:xfrm>
-          <a:prstGeom prst="rect">
-            <a:avLst/>
-          </a:prstGeom>
-          <a:noFill/>
-        </p:spPr>
-        <p:txBody>
-          <a:bodyPr wrap="square">
-            <a:spAutoFit/>
-          </a:bodyPr>
-          <a:lstStyle/>
-          <a:p>
-            <a:pPr algn="l"/>
-            <a:r>
-              <a:rPr sz="1200" b="1" i="0">
-                <a:solidFill>
-                  <a:srgbClr val="E6EDF3"/>
-                </a:solidFill>
-              </a:rPr>
-              <a:t>⚠️  Scanned PDFs</a:t>
-            </a:r>
-          </a:p>
-        </p:txBody>
-      </p:sp>
-      <p:sp>
-        <p:nvSpPr>
-          <p:cNvPr id="24" name="TextBox 23"/>
-          <p:cNvSpPr txBox="1"/>
-          <p:nvPr/>
-        </p:nvSpPr>
-        <p:spPr>
-          <a:xfrm>
-            <a:off x="4297680" y="4187952"/>
-            <a:ext cx="3383280" cy="1188720"/>
-          </a:xfrm>
-          <a:prstGeom prst="rect">
-            <a:avLst/>
-          </a:prstGeom>
-          <a:noFill/>
-        </p:spPr>
-        <p:txBody>
-          <a:bodyPr wrap="square">
-            <a:spAutoFit/>
-          </a:bodyPr>
-          <a:lstStyle/>
-          <a:p>
-            <a:pPr algn="l"/>
-            <a:r>
-              <a:rPr sz="1100" b="0" i="0">
-                <a:solidFill>
-                  <a:srgbClr val="8B949E"/>
-                </a:solidFill>
-              </a:rPr>
-              <a:t>PyMuPDF extracts embedded text only — image-based/scanned PDFs return empty text. No OCR.</a:t>
-            </a:r>
-          </a:p>
-        </p:txBody>
-      </p:sp>
-      <p:sp>
-        <p:nvSpPr>
-          <p:cNvPr id="25" name="Rectangle 24"/>
-          <p:cNvSpPr/>
-          <p:nvPr/>
-        </p:nvSpPr>
-        <p:spPr>
-          <a:xfrm>
-            <a:off x="8046720" y="3657600"/>
-            <a:ext cx="3657600" cy="1920240"/>
-          </a:xfrm>
-          <a:prstGeom prst="rect">
-            <a:avLst/>
-          </a:prstGeom>
-          <a:solidFill>
-            <a:srgbClr val="161B22"/>
-          </a:solidFill>
-          <a:ln w="9525">
-            <a:solidFill>
-              <a:srgbClr val="30363D"/>
-            </a:solidFill>
-          </a:ln>
-        </p:spPr>
-        <p:style>
-          <a:lnRef idx="1">
-            <a:schemeClr val="accent1"/>
-          </a:lnRef>
-          <a:fillRef idx="3">
-            <a:schemeClr val="accent1"/>
-          </a:fillRef>
-          <a:effectRef idx="2">
-            <a:schemeClr val="accent1"/>
-          </a:effectRef>
-          <a:fontRef idx="minor">
-            <a:schemeClr val="lt1"/>
-          </a:fontRef>
-        </p:style>
-        <p:txBody>
-          <a:bodyPr rtlCol="0" anchor="ctr"/>
-          <a:lstStyle/>
-          <a:p>
-            <a:pPr algn="ctr"/>
-          </a:p>
-        </p:txBody>
-      </p:sp>
-      <p:sp>
-        <p:nvSpPr>
-          <p:cNvPr id="26" name="Rectangle 25"/>
-          <p:cNvSpPr/>
-          <p:nvPr/>
-        </p:nvSpPr>
-        <p:spPr>
-          <a:xfrm>
-            <a:off x="8046720" y="3657600"/>
-            <a:ext cx="3657600" cy="38100"/>
-          </a:xfrm>
-          <a:prstGeom prst="rect">
-            <a:avLst/>
-          </a:prstGeom>
-          <a:solidFill>
-            <a:srgbClr val="F78166"/>
-          </a:solidFill>
-          <a:ln>
-            <a:noFill/>
-          </a:ln>
-        </p:spPr>
-        <p:style>
-          <a:lnRef idx="1">
-            <a:schemeClr val="accent1"/>
-          </a:lnRef>
-          <a:fillRef idx="3">
-            <a:schemeClr val="accent1"/>
-          </a:fillRef>
-          <a:effectRef idx="2">
-            <a:schemeClr val="accent1"/>
-          </a:effectRef>
-          <a:fontRef idx="minor">
-            <a:schemeClr val="lt1"/>
-          </a:fontRef>
-        </p:style>
-        <p:txBody>
-          <a:bodyPr rtlCol="0" anchor="ctr"/>
-          <a:lstStyle/>
-          <a:p>
-            <a:pPr algn="ctr"/>
-          </a:p>
-        </p:txBody>
-      </p:sp>
-      <p:sp>
-        <p:nvSpPr>
-          <p:cNvPr id="27" name="TextBox 26"/>
-          <p:cNvSpPr txBox="1"/>
-          <p:nvPr/>
-        </p:nvSpPr>
-        <p:spPr>
-          <a:xfrm>
-            <a:off x="8183880" y="3794760"/>
-            <a:ext cx="3383280" cy="365760"/>
-          </a:xfrm>
-          <a:prstGeom prst="rect">
-            <a:avLst/>
-          </a:prstGeom>
-          <a:noFill/>
-        </p:spPr>
-        <p:txBody>
-          <a:bodyPr wrap="square">
-            <a:spAutoFit/>
-          </a:bodyPr>
-          <a:lstStyle/>
-          <a:p>
-            <a:pPr algn="l"/>
-            <a:r>
-              <a:rPr sz="1200" b="1" i="0">
-                <a:solidFill>
-                  <a:srgbClr val="E6EDF3"/>
-                </a:solidFill>
-              </a:rPr>
-              <a:t>⚠️  No auth / multi-user</a:t>
-            </a:r>
-          </a:p>
-        </p:txBody>
-      </p:sp>
-      <p:sp>
-        <p:nvSpPr>
-          <p:cNvPr id="28" name="TextBox 27"/>
-          <p:cNvSpPr txBox="1"/>
-          <p:nvPr/>
-        </p:nvSpPr>
-        <p:spPr>
-          <a:xfrm>
-            <a:off x="8183880" y="4187952"/>
-            <a:ext cx="3383280" cy="1188720"/>
-          </a:xfrm>
-          <a:prstGeom prst="rect">
-            <a:avLst/>
-          </a:prstGeom>
-          <a:noFill/>
-        </p:spPr>
-        <p:txBody>
-          <a:bodyPr wrap="square">
-            <a:spAutoFit/>
-          </a:bodyPr>
-          <a:lstStyle/>
-          <a:p>
-            <a:pPr algn="l"/>
-            <a:r>
-              <a:rPr sz="1100" b="0" i="0">
-                <a:solidFill>
-                  <a:srgbClr val="8B949E"/>
-                </a:solidFill>
-              </a:rPr>
-              <a:t>Single shared state. Not suitable for multi-user deployment without session isolation.</a:t>
+              <a:t>http://localhost:8000   ·   docker compose up -d &amp;&amp; uvicorn backend.main:app --reload</a:t>
             </a:r>
           </a:p>
         </p:txBody>
@@ -5042,7 +4661,7 @@
             <a:avLst/>
           </a:prstGeom>
           <a:solidFill>
-            <a:srgbClr val="3FB950"/>
+            <a:srgbClr val="58A6FF"/>
           </a:solidFill>
           <a:ln>
             <a:noFill/>
@@ -5096,10 +4715,10 @@
             <a:r>
               <a:rPr sz="1300" b="1" i="0">
                 <a:solidFill>
-                  <a:srgbClr val="3FB950"/>
-                </a:solidFill>
-              </a:rPr>
-              <a:t>🚀  High impact</a:t>
+                  <a:srgbClr val="58A6FF"/>
+                </a:solidFill>
+              </a:rPr>
+              <a:t>🔧  Reliability</a:t>
             </a:r>
           </a:p>
         </p:txBody>
@@ -5133,7 +4752,7 @@
                   <a:srgbClr val="E6EDF3"/>
                 </a:solidFill>
               </a:rPr>
-              <a:t>• Hybrid search (BM25 + vector)</a:t>
+              <a:t>• OCR for scanned PDFs</a:t>
             </a:r>
           </a:p>
         </p:txBody>
@@ -5147,7 +4766,7 @@
         <p:spPr>
           <a:xfrm>
             <a:off x="411480" y="2286000"/>
-            <a:ext cx="3520440" cy="502920"/>
+            <a:ext cx="3520440" cy="548640"/>
           </a:xfrm>
           <a:prstGeom prst="rect">
             <a:avLst/>
@@ -5162,12 +4781,12 @@
           <a:p>
             <a:pPr algn="l"/>
             <a:r>
-              <a:rPr sz="1100" b="0" i="0">
+              <a:rPr sz="1000" b="0" i="0">
                 <a:solidFill>
                   <a:srgbClr val="8B949E"/>
                 </a:solidFill>
               </a:rPr>
-              <a:t>Postgres tsvector — no new infra. Covers keyword queries dense retrieval misses.</a:t>
+              <a:t>Tesseract or Google Vision fallback when PyMuPDF returns empty text — currently image-based PDFs produce no chunks.</a:t>
             </a:r>
           </a:p>
         </p:txBody>
@@ -5180,7 +4799,7 @@
         </p:nvSpPr>
         <p:spPr>
           <a:xfrm>
-            <a:off x="411480" y="2971800"/>
+            <a:off x="411480" y="3017520"/>
             <a:ext cx="3520440" cy="274320"/>
           </a:xfrm>
           <a:prstGeom prst="rect">
@@ -5201,7 +4820,7 @@
                   <a:srgbClr val="E6EDF3"/>
                 </a:solidFill>
               </a:rPr>
-              <a:t>• Re-ranking</a:t>
+              <a:t>• Upload queue</a:t>
             </a:r>
           </a:p>
         </p:txBody>
@@ -5214,8 +4833,8 @@
         </p:nvSpPr>
         <p:spPr>
           <a:xfrm>
-            <a:off x="411480" y="3246120"/>
-            <a:ext cx="3520440" cy="502920"/>
+            <a:off x="411480" y="3291840"/>
+            <a:ext cx="3520440" cy="548640"/>
           </a:xfrm>
           <a:prstGeom prst="rect">
             <a:avLst/>
@@ -5230,12 +4849,12 @@
           <a:p>
             <a:pPr algn="l"/>
             <a:r>
-              <a:rPr sz="1100" b="0" i="0">
+              <a:rPr sz="1000" b="0" i="0">
                 <a:solidFill>
                   <a:srgbClr val="8B949E"/>
                 </a:solidFill>
               </a:rPr>
-              <a:t>Cross-encoder pass after retrieval to filter irrelevant chunks before generation.</a:t>
+              <a:t>Background job for large PDFs — free the HTTP request immediately and let the client poll for status.</a:t>
             </a:r>
           </a:p>
         </p:txBody>
@@ -5248,7 +4867,7 @@
         </p:nvSpPr>
         <p:spPr>
           <a:xfrm>
-            <a:off x="411480" y="3931920"/>
+            <a:off x="411480" y="4023360"/>
             <a:ext cx="3520440" cy="274320"/>
           </a:xfrm>
           <a:prstGeom prst="rect">
@@ -5269,7 +4888,7 @@
                   <a:srgbClr val="E6EDF3"/>
                 </a:solidFill>
               </a:rPr>
-              <a:t>• Duplicate detection</a:t>
+              <a:t>• Auth + multi-user</a:t>
             </a:r>
           </a:p>
         </p:txBody>
@@ -5282,8 +4901,8 @@
         </p:nvSpPr>
         <p:spPr>
           <a:xfrm>
-            <a:off x="411480" y="4206240"/>
-            <a:ext cx="3520440" cy="502920"/>
+            <a:off x="411480" y="4297680"/>
+            <a:ext cx="3520440" cy="548640"/>
           </a:xfrm>
           <a:prstGeom prst="rect">
             <a:avLst/>
@@ -5298,12 +4917,12 @@
           <a:p>
             <a:pPr algn="l"/>
             <a:r>
-              <a:rPr sz="1100" b="0" i="0">
+              <a:rPr sz="1000" b="0" i="0">
                 <a:solidFill>
                   <a:srgbClr val="8B949E"/>
                 </a:solidFill>
               </a:rPr>
-              <a:t>Skip re-embedding when doc_id already in doc_meta — instant reload for same file.</a:t>
+              <a:t>Session isolation so multiple users can each have their own document state without shared _state.</a:t>
             </a:r>
           </a:p>
         </p:txBody>
@@ -5459,7 +5078,7 @@
                   <a:srgbClr val="E6EDF3"/>
                 </a:solidFill>
               </a:rPr>
-              <a:t>• Parent-child chunking</a:t>
+              <a:t>• Query expansion / HyDE</a:t>
             </a:r>
           </a:p>
         </p:txBody>
@@ -5473,7 +5092,7 @@
         <p:spPr>
           <a:xfrm>
             <a:off x="4334256" y="2286000"/>
-            <a:ext cx="3520440" cy="502920"/>
+            <a:ext cx="3520440" cy="548640"/>
           </a:xfrm>
           <a:prstGeom prst="rect">
             <a:avLst/>
@@ -5488,12 +5107,12 @@
           <a:p>
             <a:pPr algn="l"/>
             <a:r>
-              <a:rPr sz="1100" b="0" i="0">
+              <a:rPr sz="1000" b="0" i="0">
                 <a:solidFill>
                   <a:srgbClr val="8B949E"/>
                 </a:solidFill>
               </a:rPr>
-              <a:t>Store small chunks for retrieval precision; return surrounding parent context to the LLM.</a:t>
+              <a:t>Generate a hypothetical answer, embed it, use that for retrieval — improves recall on vague or abstract questions.</a:t>
             </a:r>
           </a:p>
         </p:txBody>
@@ -5506,7 +5125,7 @@
         </p:nvSpPr>
         <p:spPr>
           <a:xfrm>
-            <a:off x="4334256" y="2971800"/>
+            <a:off x="4334256" y="3017520"/>
             <a:ext cx="3520440" cy="274320"/>
           </a:xfrm>
           <a:prstGeom prst="rect">
@@ -5527,7 +5146,7 @@
                   <a:srgbClr val="E6EDF3"/>
                 </a:solidFill>
               </a:rPr>
-              <a:t>• Similarity scores in UI</a:t>
+              <a:t>• Structured chunk types</a:t>
             </a:r>
           </a:p>
         </p:txBody>
@@ -5540,8 +5159,8 @@
         </p:nvSpPr>
         <p:spPr>
           <a:xfrm>
-            <a:off x="4334256" y="3246120"/>
-            <a:ext cx="3520440" cy="502920"/>
+            <a:off x="4334256" y="3291840"/>
+            <a:ext cx="3520440" cy="548640"/>
           </a:xfrm>
           <a:prstGeom prst="rect">
             <a:avLst/>
@@ -5556,12 +5175,12 @@
           <a:p>
             <a:pPr algn="l"/>
             <a:r>
-              <a:rPr sz="1100" b="0" i="0">
+              <a:rPr sz="1000" b="0" i="0">
                 <a:solidFill>
                   <a:srgbClr val="8B949E"/>
                 </a:solidFill>
               </a:rPr>
-              <a:t>Show retrieval confidence alongside citations so users can judge answer reliability.</a:t>
+              <a:t>Detect headings, tables, and lists in PDFs and split at structural boundaries rather than sentence boundaries.</a:t>
             </a:r>
           </a:p>
         </p:txBody>
@@ -5574,7 +5193,7 @@
         </p:nvSpPr>
         <p:spPr>
           <a:xfrm>
-            <a:off x="4334256" y="3931920"/>
+            <a:off x="4334256" y="4023360"/>
             <a:ext cx="3520440" cy="274320"/>
           </a:xfrm>
           <a:prstGeom prst="rect">
@@ -5595,7 +5214,7 @@
                   <a:srgbClr val="E6EDF3"/>
                 </a:solidFill>
               </a:rPr>
-              <a:t>• Multi-document support</a:t>
+              <a:t>• Eval harness</a:t>
             </a:r>
           </a:p>
         </p:txBody>
@@ -5608,8 +5227,8 @@
         </p:nvSpPr>
         <p:spPr>
           <a:xfrm>
-            <a:off x="4334256" y="4206240"/>
-            <a:ext cx="3520440" cy="502920"/>
+            <a:off x="4334256" y="4297680"/>
+            <a:ext cx="3520440" cy="548640"/>
           </a:xfrm>
           <a:prstGeom prst="rect">
             <a:avLst/>
@@ -5624,12 +5243,12 @@
           <a:p>
             <a:pPr algn="l"/>
             <a:r>
-              <a:rPr sz="1100" b="0" i="0">
+              <a:rPr sz="1000" b="0" i="0">
                 <a:solidFill>
                   <a:srgbClr val="8B949E"/>
                 </a:solidFill>
               </a:rPr>
-              <a:t>Doc library with selector — query across multiple PDFs with per-doc filtering.</a:t>
+              <a:t>Automated Q&amp;A pairs against known answers to measure retrieval precision, recall, and answer faithfulness.</a:t>
             </a:r>
           </a:p>
         </p:txBody>
@@ -5694,7 +5313,7 @@
             <a:avLst/>
           </a:prstGeom>
           <a:solidFill>
-            <a:srgbClr val="58A6FF"/>
+            <a:srgbClr val="3FB950"/>
           </a:solidFill>
           <a:ln>
             <a:noFill/>
@@ -5748,10 +5367,10 @@
             <a:r>
               <a:rPr sz="1300" b="1" i="0">
                 <a:solidFill>
-                  <a:srgbClr val="58A6FF"/>
-                </a:solidFill>
-              </a:rPr>
-              <a:t>🔧  Reliability</a:t>
+                  <a:srgbClr val="3FB950"/>
+                </a:solidFill>
+              </a:rPr>
+              <a:t>📦  Scale</a:t>
             </a:r>
           </a:p>
         </p:txBody>
@@ -5785,7 +5404,7 @@
                   <a:srgbClr val="E6EDF3"/>
                 </a:solidFill>
               </a:rPr>
-              <a:t>• OCR for scanned PDFs</a:t>
+              <a:t>• Multi-document library</a:t>
             </a:r>
           </a:p>
         </p:txBody>
@@ -5799,7 +5418,7 @@
         <p:spPr>
           <a:xfrm>
             <a:off x="8257032" y="2286000"/>
-            <a:ext cx="3520440" cy="502920"/>
+            <a:ext cx="3520440" cy="548640"/>
           </a:xfrm>
           <a:prstGeom prst="rect">
             <a:avLst/>
@@ -5814,12 +5433,12 @@
           <a:p>
             <a:pPr algn="l"/>
             <a:r>
-              <a:rPr sz="1100" b="0" i="0">
+              <a:rPr sz="1000" b="0" i="0">
                 <a:solidFill>
                   <a:srgbClr val="8B949E"/>
                 </a:solidFill>
               </a:rPr>
-              <a:t>Tesseract or Google Vision fallback when PyMuPDF returns empty text.</a:t>
+              <a:t>Doc picker with per-doc metadata — query across multiple PDFs with doc_id filtering.</a:t>
             </a:r>
           </a:p>
         </p:txBody>
@@ -5832,7 +5451,7 @@
         </p:nvSpPr>
         <p:spPr>
           <a:xfrm>
-            <a:off x="8257032" y="2971800"/>
+            <a:off x="8257032" y="3017520"/>
             <a:ext cx="3520440" cy="274320"/>
           </a:xfrm>
           <a:prstGeom prst="rect">
@@ -5853,7 +5472,7 @@
                   <a:srgbClr val="E6EDF3"/>
                 </a:solidFill>
               </a:rPr>
-              <a:t>• Upload queue</a:t>
+              <a:t>• Streaming embed batches</a:t>
             </a:r>
           </a:p>
         </p:txBody>
@@ -5866,8 +5485,8 @@
         </p:nvSpPr>
         <p:spPr>
           <a:xfrm>
-            <a:off x="8257032" y="3246120"/>
-            <a:ext cx="3520440" cy="502920"/>
+            <a:off x="8257032" y="3291840"/>
+            <a:ext cx="3520440" cy="548640"/>
           </a:xfrm>
           <a:prstGeom prst="rect">
             <a:avLst/>
@@ -5882,12 +5501,12 @@
           <a:p>
             <a:pPr algn="l"/>
             <a:r>
-              <a:rPr sz="1100" b="0" i="0">
+              <a:rPr sz="1000" b="0" i="0">
                 <a:solidFill>
                   <a:srgbClr val="8B949E"/>
                 </a:solidFill>
               </a:rPr>
-              <a:t>Background job for large PDFs — free the HTTP request immediately, poll for status.</a:t>
+              <a:t>For very large docs, stream embedding in fixed batches rather than one giant asyncio.gather to bound peak memory.</a:t>
             </a:r>
           </a:p>
         </p:txBody>
@@ -5900,7 +5519,7 @@
         </p:nvSpPr>
         <p:spPr>
           <a:xfrm>
-            <a:off x="8257032" y="3931920"/>
+            <a:off x="8257032" y="4023360"/>
             <a:ext cx="3520440" cy="274320"/>
           </a:xfrm>
           <a:prstGeom prst="rect">
@@ -5921,7 +5540,7 @@
                   <a:srgbClr val="E6EDF3"/>
                 </a:solidFill>
               </a:rPr>
-              <a:t>• Auth + multi-user</a:t>
+              <a:t>• Persistent conversation</a:t>
             </a:r>
           </a:p>
         </p:txBody>
@@ -5934,8 +5553,8 @@
         </p:nvSpPr>
         <p:spPr>
           <a:xfrm>
-            <a:off x="8257032" y="4206240"/>
-            <a:ext cx="3520440" cy="502920"/>
+            <a:off x="8257032" y="4297680"/>
+            <a:ext cx="3520440" cy="548640"/>
           </a:xfrm>
           <a:prstGeom prst="rect">
             <a:avLst/>
@@ -5950,12 +5569,12 @@
           <a:p>
             <a:pPr algn="l"/>
             <a:r>
-              <a:rPr sz="1100" b="0" i="0">
+              <a:rPr sz="1000" b="0" i="0">
                 <a:solidFill>
                   <a:srgbClr val="8B949E"/>
                 </a:solidFill>
               </a:rPr>
-              <a:t>Session isolation so multiple users can each have their own document state.</a:t>
+              <a:t>Store chat history per session so follow-up questions can reference earlier answers.</a:t>
             </a:r>
           </a:p>
         </p:txBody>
@@ -5988,50 +5607,7 @@
       <p:grpSpPr/>
       <p:sp>
         <p:nvSpPr>
-          <p:cNvPr id="2" name="Rectangle 1"/>
-          <p:cNvSpPr/>
-          <p:nvPr/>
-        </p:nvSpPr>
-        <p:spPr>
-          <a:xfrm>
-            <a:off x="0" y="0"/>
-            <a:ext cx="12188952" cy="6858000"/>
-          </a:xfrm>
-          <a:prstGeom prst="rect">
-            <a:avLst/>
-          </a:prstGeom>
-          <a:solidFill>
-            <a:srgbClr val="0D1117"/>
-          </a:solidFill>
-          <a:ln>
-            <a:noFill/>
-          </a:ln>
-        </p:spPr>
-        <p:style>
-          <a:lnRef idx="1">
-            <a:schemeClr val="accent1"/>
-          </a:lnRef>
-          <a:fillRef idx="3">
-            <a:schemeClr val="accent1"/>
-          </a:fillRef>
-          <a:effectRef idx="2">
-            <a:schemeClr val="accent1"/>
-          </a:effectRef>
-          <a:fontRef idx="minor">
-            <a:schemeClr val="lt1"/>
-          </a:fontRef>
-        </p:style>
-        <p:txBody>
-          <a:bodyPr rtlCol="0" anchor="ctr"/>
-          <a:lstStyle/>
-          <a:p>
-            <a:pPr algn="ctr"/>
-          </a:p>
-        </p:txBody>
-      </p:sp>
-      <p:sp>
-        <p:nvSpPr>
-          <p:cNvPr id="3" name="TextBox 2"/>
+          <p:cNvPr id="2" name="TextBox 1"/>
           <p:cNvSpPr txBox="1"/>
           <p:nvPr/>
         </p:nvSpPr>
@@ -6065,7 +5641,7 @@
       </p:sp>
       <p:sp>
         <p:nvSpPr>
-          <p:cNvPr id="4" name="TextBox 3"/>
+          <p:cNvPr id="3" name="TextBox 2"/>
           <p:cNvSpPr txBox="1"/>
           <p:nvPr/>
         </p:nvSpPr>
@@ -6099,7 +5675,7 @@
       </p:sp>
       <p:sp>
         <p:nvSpPr>
-          <p:cNvPr id="5" name="TextBox 4"/>
+          <p:cNvPr id="4" name="TextBox 3"/>
           <p:cNvSpPr txBox="1"/>
           <p:nvPr/>
         </p:nvSpPr>
@@ -6133,7 +5709,7 @@
       </p:sp>
       <p:sp>
         <p:nvSpPr>
-          <p:cNvPr id="6" name="Rectangle 5"/>
+          <p:cNvPr id="5" name="Rectangle 4"/>
           <p:cNvSpPr/>
           <p:nvPr/>
         </p:nvSpPr>
@@ -6178,7 +5754,7 @@
       </p:sp>
       <p:sp>
         <p:nvSpPr>
-          <p:cNvPr id="7" name="TextBox 6"/>
+          <p:cNvPr id="6" name="TextBox 5"/>
           <p:cNvSpPr txBox="1"/>
           <p:nvPr/>
         </p:nvSpPr>
@@ -6212,34 +5788,68 @@
       </p:sp>
       <p:sp>
         <p:nvSpPr>
+          <p:cNvPr id="7" name="TextBox 6"/>
+          <p:cNvSpPr txBox="1"/>
+          <p:nvPr/>
+        </p:nvSpPr>
+        <p:spPr>
+          <a:xfrm>
+            <a:off x="731520" y="4937760"/>
+            <a:ext cx="2743200" cy="365760"/>
+          </a:xfrm>
+          <a:prstGeom prst="rect">
+            <a:avLst/>
+          </a:prstGeom>
+          <a:noFill/>
+        </p:spPr>
+        <p:txBody>
+          <a:bodyPr wrap="square">
+            <a:spAutoFit/>
+          </a:bodyPr>
+          <a:lstStyle/>
+          <a:p>
+            <a:pPr algn="ctr"/>
+            <a:r>
+              <a:rPr sz="1100" b="0" i="0">
+                <a:solidFill>
+                  <a:srgbClr val="8B949E"/>
+                </a:solidFill>
+              </a:rPr>
+              <a:t>🔍 Hybrid BM25 + vector</a:t>
+            </a:r>
+          </a:p>
+        </p:txBody>
+      </p:sp>
+      <p:sp>
+        <p:nvSpPr>
           <p:cNvPr id="8" name="TextBox 7"/>
           <p:cNvSpPr txBox="1"/>
           <p:nvPr/>
         </p:nvSpPr>
         <p:spPr>
           <a:xfrm>
-            <a:off x="914400" y="4937760"/>
-            <a:ext cx="2560320" cy="365760"/>
-          </a:xfrm>
-          <a:prstGeom prst="rect">
-            <a:avLst/>
-          </a:prstGeom>
-          <a:noFill/>
-        </p:spPr>
-        <p:txBody>
-          <a:bodyPr wrap="square">
-            <a:spAutoFit/>
-          </a:bodyPr>
-          <a:lstStyle/>
-          <a:p>
-            <a:pPr algn="ctr"/>
-            <a:r>
-              <a:rPr sz="1200" b="0" i="0">
+            <a:off x="3474720" y="4937760"/>
+            <a:ext cx="2743200" cy="365760"/>
+          </a:xfrm>
+          <a:prstGeom prst="rect">
+            <a:avLst/>
+          </a:prstGeom>
+          <a:noFill/>
+        </p:spPr>
+        <p:txBody>
+          <a:bodyPr wrap="square">
+            <a:spAutoFit/>
+          </a:bodyPr>
+          <a:lstStyle/>
+          <a:p>
+            <a:pPr algn="ctr"/>
+            <a:r>
+              <a:rPr sz="1100" b="0" i="0">
                 <a:solidFill>
                   <a:srgbClr val="8B949E"/>
                 </a:solidFill>
               </a:rPr>
-              <a:t>📄 PyMuPDF extraction</a:t>
+              <a:t>🔃 Gemini re-ranking</a:t>
             </a:r>
           </a:p>
         </p:txBody>
@@ -6252,28 +5862,28 @@
         </p:nvSpPr>
         <p:spPr>
           <a:xfrm>
-            <a:off x="3474720" y="4937760"/>
-            <a:ext cx="2560320" cy="365760"/>
-          </a:xfrm>
-          <a:prstGeom prst="rect">
-            <a:avLst/>
-          </a:prstGeom>
-          <a:noFill/>
-        </p:spPr>
-        <p:txBody>
-          <a:bodyPr wrap="square">
-            <a:spAutoFit/>
-          </a:bodyPr>
-          <a:lstStyle/>
-          <a:p>
-            <a:pPr algn="ctr"/>
-            <a:r>
-              <a:rPr sz="1200" b="0" i="0">
+            <a:off x="6217920" y="4937760"/>
+            <a:ext cx="2743200" cy="365760"/>
+          </a:xfrm>
+          <a:prstGeom prst="rect">
+            <a:avLst/>
+          </a:prstGeom>
+          <a:noFill/>
+        </p:spPr>
+        <p:txBody>
+          <a:bodyPr wrap="square">
+            <a:spAutoFit/>
+          </a:bodyPr>
+          <a:lstStyle/>
+          <a:p>
+            <a:pPr algn="ctr"/>
+            <a:r>
+              <a:rPr sz="1100" b="0" i="0">
                 <a:solidFill>
                   <a:srgbClr val="8B949E"/>
                 </a:solidFill>
               </a:rPr>
-              <a:t>🧠 Gemini embeddings</a:t>
+              <a:t>🪟 Parent-child chunks</a:t>
             </a:r>
           </a:p>
         </p:txBody>
@@ -6286,62 +5896,28 @@
         </p:nvSpPr>
         <p:spPr>
           <a:xfrm>
-            <a:off x="6035040" y="4937760"/>
-            <a:ext cx="2560320" cy="365760"/>
-          </a:xfrm>
-          <a:prstGeom prst="rect">
-            <a:avLst/>
-          </a:prstGeom>
-          <a:noFill/>
-        </p:spPr>
-        <p:txBody>
-          <a:bodyPr wrap="square">
-            <a:spAutoFit/>
-          </a:bodyPr>
-          <a:lstStyle/>
-          <a:p>
-            <a:pPr algn="ctr"/>
-            <a:r>
-              <a:rPr sz="1200" b="0" i="0">
+            <a:off x="8961120" y="4937760"/>
+            <a:ext cx="2743200" cy="365760"/>
+          </a:xfrm>
+          <a:prstGeom prst="rect">
+            <a:avLst/>
+          </a:prstGeom>
+          <a:noFill/>
+        </p:spPr>
+        <p:txBody>
+          <a:bodyPr wrap="square">
+            <a:spAutoFit/>
+          </a:bodyPr>
+          <a:lstStyle/>
+          <a:p>
+            <a:pPr algn="ctr"/>
+            <a:r>
+              <a:rPr sz="1100" b="0" i="0">
                 <a:solidFill>
                   <a:srgbClr val="8B949E"/>
                 </a:solidFill>
               </a:rPr>
-              <a:t>🗄️ pgvector HNSW</a:t>
-            </a:r>
-          </a:p>
-        </p:txBody>
-      </p:sp>
-      <p:sp>
-        <p:nvSpPr>
-          <p:cNvPr id="11" name="TextBox 10"/>
-          <p:cNvSpPr txBox="1"/>
-          <p:nvPr/>
-        </p:nvSpPr>
-        <p:spPr>
-          <a:xfrm>
-            <a:off x="8595360" y="4937760"/>
-            <a:ext cx="2560320" cy="365760"/>
-          </a:xfrm>
-          <a:prstGeom prst="rect">
-            <a:avLst/>
-          </a:prstGeom>
-          <a:noFill/>
-        </p:spPr>
-        <p:txBody>
-          <a:bodyPr wrap="square">
-            <a:spAutoFit/>
-          </a:bodyPr>
-          <a:lstStyle/>
-          <a:p>
-            <a:pPr algn="ctr"/>
-            <a:r>
-              <a:rPr sz="1200" b="0" i="0">
-                <a:solidFill>
-                  <a:srgbClr val="8B949E"/>
-                </a:solidFill>
-              </a:rPr>
-              <a:t>⚡ FastAPI + asyncpg</a:t>
+              <a:t>⚡ Dedup + similarity scores</a:t>
             </a:r>
           </a:p>
         </p:txBody>
@@ -9085,8 +8661,8 @@
                   <a:srgbClr val="8B949E"/>
                 </a:solidFill>
               </a:rPr>
-              <a:t>chunks table
-doc_meta table
+              <a:t>chunks+parent_text
+doc_meta
 pgvector HNSW</a:t>
             </a:r>
           </a:p>
@@ -9427,7 +9003,7 @@
                   <a:srgbClr val="E6EDF3"/>
                 </a:solidFill>
               </a:rPr>
-              <a:t>pgvector</a:t>
+              <a:t>Hybrid search</a:t>
             </a:r>
           </a:p>
         </p:txBody>
@@ -9461,9 +9037,8 @@
                   <a:srgbClr val="8B949E"/>
                 </a:solidFill>
               </a:rPr>
-              <a:t>cosine search
-top-k (auto)
-HNSW index</a:t>
+              <a:t>BM25 + pgvector
+RRF fusion</a:t>
             </a:r>
           </a:p>
         </p:txBody>
@@ -9487,7 +9062,7 @@
           </a:solidFill>
           <a:ln w="9525">
             <a:solidFill>
-              <a:srgbClr val="4285F4"/>
+              <a:srgbClr val="58A6FF"/>
             </a:solidFill>
           </a:ln>
         </p:spPr>
@@ -9542,7 +9117,7 @@
                   <a:srgbClr val="E6EDF3"/>
                 </a:solidFill>
               </a:rPr>
-              <a:t>✍️</a:t>
+              <a:t>🔃</a:t>
             </a:r>
           </a:p>
         </p:txBody>
@@ -9576,7 +9151,7 @@
                   <a:srgbClr val="E6EDF3"/>
                 </a:solidFill>
               </a:rPr>
-              <a:t>Gemini Flash</a:t>
+              <a:t>Re-rank</a:t>
             </a:r>
           </a:p>
         </p:txBody>
@@ -9610,9 +9185,8 @@
                   <a:srgbClr val="8B949E"/>
                 </a:solidFill>
               </a:rPr>
-              <a:t>2.5 Flash
-grounded answer
-streamed SSE</a:t>
+              <a:t>Gemini ranks
+top k/2</a:t>
             </a:r>
           </a:p>
         </p:txBody>
@@ -9760,8 +9334,8 @@
                 </a:solidFill>
               </a:rPr>
               <a:t>[Chunk N] cites
-or I don't know
-SSE stream</a:t>
+similarity %
+SSE</a:t>
             </a:r>
           </a:p>
         </p:txBody>
@@ -10339,7 +9913,7 @@
                   <a:srgbClr val="8B949E"/>
                 </a:solidFill>
               </a:rPr>
-              <a:t>tiktoken counts total tokens → compute_params() selects chunk_size and k. Sentence-boundary splits with 64-token overlap preserve context across boundaries.</a:t>
+              <a:t>tiktoken counts total tokens → compute_params() selects chunk_size and k. Sentence-boundary splits with 64-token overlap. Parent text (prev+self+next) stored for LLM context.</a:t>
             </a:r>
           </a:p>
         </p:txBody>
@@ -10791,7 +10365,7 @@
                   <a:srgbClr val="8B949E"/>
                 </a:solidFill>
               </a:rPr>
-              <a:t>Chunks + vectors written to chunks table. Chosen k and chunk count persisted in doc_meta so they survive server restarts without re-upload.</a:t>
+              <a:t>Chunks + vectors + parent_text written to chunks table. doc_meta persists chunk_count and k. If same PDF is re-uploaded, doc_exists() detects the SHA-256 match and skips all of the above.</a:t>
             </a:r>
           </a:p>
         </p:txBody>
@@ -10870,7 +10444,7 @@
                   <a:srgbClr val="D2A8FF"/>
                 </a:solidFill>
               </a:rPr>
-              <a:t>HNSW index on embedding column</a:t>
+              <a:t>HNSW index · GIN tsvector index</a:t>
             </a:r>
           </a:p>
         </p:txBody>
@@ -11392,7 +10966,7 @@
                   <a:srgbClr val="E6EDF3"/>
                 </a:solidFill>
               </a:rPr>
-              <a:t>Top-k search</a:t>
+              <a:t>Hybrid search</a:t>
             </a:r>
           </a:p>
         </p:txBody>
@@ -11426,7 +11000,7 @@
                   <a:srgbClr val="8B949E"/>
                 </a:solidFill>
               </a:rPr>
-              <a:t>cosine · pgvector</a:t>
+              <a:t>BM25 + vector RRF</a:t>
             </a:r>
           </a:p>
         </p:txBody>
@@ -11494,7 +11068,7 @@
                   <a:srgbClr val="E6EDF3"/>
                 </a:solidFill>
               </a:rPr>
-              <a:t>✍️</a:t>
+              <a:t>🔃</a:t>
             </a:r>
           </a:p>
         </p:txBody>
@@ -11528,7 +11102,7 @@
                   <a:srgbClr val="E6EDF3"/>
                 </a:solidFill>
               </a:rPr>
-              <a:t>Generate</a:t>
+              <a:t>Re-rank</a:t>
             </a:r>
           </a:p>
         </p:txBody>
@@ -11562,7 +11136,7 @@
                   <a:srgbClr val="8B949E"/>
                 </a:solidFill>
               </a:rPr>
-              <a:t>Gemini 2.5 Flash</a:t>
+              <a:t>Gemini · top k/2</a:t>
             </a:r>
           </a:p>
         </p:txBody>
@@ -11811,7 +11385,7 @@
                   <a:srgbClr val="8B949E"/>
                 </a:solidFill>
               </a:rPr>
-              <a:t>"Answer using ONLY the provided context. If the context doesn't contain enough information, respond with exactly: "I don't know." Cite sources as [Chunk N] inline throughout your answer."</a:t>
+              <a:t>"Answer using ONLY the provided context. If insufficient: "I don't know." Cite sources as [Chunk N] inline."</a:t>
             </a:r>
           </a:p>
         </p:txBody>
@@ -11924,7 +11498,7 @@
                   <a:srgbClr val="8B949E"/>
                 </a:solidFill>
               </a:rPr>
-              <a:t>If pgvector returns zero results for the doc_id, the answer is short-circuited to 'I don’t know.' before the LLM is called — no hallucination possible on empty retrieval.</a:t>
+              <a:t>If pgvector returns zero results, the answer is short-circuited to 'I don't know.' before the LLM is called — no hallucination possible on empty retrieval.</a:t>
             </a:r>
           </a:p>
         </p:txBody>
@@ -13784,7 +13358,7 @@
                   <a:srgbClr val="8B949E"/>
                 </a:solidFill>
               </a:rPr>
-              <a:t>HNSW needs no pre-training (unlike IVFFlat). One service handles relational + vector search. No extra infra.</a:t>
+              <a:t>HNSW needs no pre-training. One service handles relational + vector + full-text search. No extra infra.</a:t>
             </a:r>
           </a:p>
         </p:txBody>
@@ -13886,7 +13460,7 @@
                   <a:srgbClr val="8B949E"/>
                 </a:solidFill>
               </a:rPr>
-              <a:t>Binary wire protocol — lower latency than psycopg. No ORM overhead for a two-table schema.</a:t>
+              <a:t>Binary wire protocol — lower latency than psycopg. No ORM overhead for a minimal schema.</a:t>
             </a:r>
           </a:p>
         </p:txBody>
@@ -13988,7 +13562,7 @@
                   <a:srgbClr val="8B949E"/>
                 </a:solidFill>
               </a:rPr>
-              <a:t>Fast, cost-effective, streamed output via SSE for a responsive UX.</a:t>
+              <a:t>Fast, cost-effective, streamed output via SSE for a responsive UX. Also used for re-ranking.</a:t>
             </a:r>
           </a:p>
         </p:txBody>
@@ -14884,50 +14458,7 @@
       <p:grpSpPr/>
       <p:sp>
         <p:nvSpPr>
-          <p:cNvPr id="2" name="Rectangle 1"/>
-          <p:cNvSpPr/>
-          <p:nvPr/>
-        </p:nvSpPr>
-        <p:spPr>
-          <a:xfrm>
-            <a:off x="0" y="0"/>
-            <a:ext cx="12188952" cy="6858000"/>
-          </a:xfrm>
-          <a:prstGeom prst="rect">
-            <a:avLst/>
-          </a:prstGeom>
-          <a:solidFill>
-            <a:srgbClr val="0D1117"/>
-          </a:solidFill>
-          <a:ln>
-            <a:noFill/>
-          </a:ln>
-        </p:spPr>
-        <p:style>
-          <a:lnRef idx="1">
-            <a:schemeClr val="accent1"/>
-          </a:lnRef>
-          <a:fillRef idx="3">
-            <a:schemeClr val="accent1"/>
-          </a:fillRef>
-          <a:effectRef idx="2">
-            <a:schemeClr val="accent1"/>
-          </a:effectRef>
-          <a:fontRef idx="minor">
-            <a:schemeClr val="lt1"/>
-          </a:fontRef>
-        </p:style>
-        <p:txBody>
-          <a:bodyPr rtlCol="0" anchor="ctr"/>
-          <a:lstStyle/>
-          <a:p>
-            <a:pPr algn="ctr"/>
-          </a:p>
-        </p:txBody>
-      </p:sp>
-      <p:sp>
-        <p:nvSpPr>
-          <p:cNvPr id="3" name="TextBox 2"/>
+          <p:cNvPr id="2" name="TextBox 1"/>
           <p:cNvSpPr txBox="1"/>
           <p:nvPr/>
         </p:nvSpPr>
@@ -14954,14 +14485,14 @@
                   <a:srgbClr val="58A6FF"/>
                 </a:solidFill>
               </a:rPr>
-              <a:t>DEMONSTRATION</a:t>
-            </a:r>
-          </a:p>
-        </p:txBody>
-      </p:sp>
-      <p:sp>
-        <p:nvSpPr>
-          <p:cNvPr id="4" name="TextBox 3"/>
+              <a:t>ADDITIONAL FEATURES</a:t>
+            </a:r>
+          </a:p>
+        </p:txBody>
+      </p:sp>
+      <p:sp>
+        <p:nvSpPr>
+          <p:cNvPr id="3" name="TextBox 2"/>
           <p:cNvSpPr txBox="1"/>
           <p:nvPr/>
         </p:nvSpPr>
@@ -14988,14 +14519,14 @@
                   <a:srgbClr val="E6EDF3"/>
                 </a:solidFill>
               </a:rPr>
-              <a:t>Live demo</a:t>
-            </a:r>
-          </a:p>
-        </p:txBody>
-      </p:sp>
-      <p:sp>
-        <p:nvSpPr>
-          <p:cNvPr id="5" name="Rectangle 4"/>
+              <a:t>Retrieval quality improvements</a:t>
+            </a:r>
+          </a:p>
+        </p:txBody>
+      </p:sp>
+      <p:sp>
+        <p:nvSpPr>
+          <p:cNvPr id="4" name="Rectangle 3"/>
           <p:cNvSpPr/>
           <p:nvPr/>
         </p:nvSpPr>
@@ -15038,24 +14569,24 @@
       </p:sp>
       <p:sp>
         <p:nvSpPr>
-          <p:cNvPr id="6" name="Rectangle 5"/>
+          <p:cNvPr id="5" name="Rectangle 4"/>
           <p:cNvSpPr/>
           <p:nvPr/>
         </p:nvSpPr>
         <p:spPr>
           <a:xfrm>
-            <a:off x="548640" y="1463040"/>
-            <a:ext cx="11091672" cy="4114800"/>
+            <a:off x="274320" y="1463040"/>
+            <a:ext cx="3520440" cy="2286000"/>
           </a:xfrm>
           <a:prstGeom prst="rect">
             <a:avLst/>
           </a:prstGeom>
           <a:solidFill>
-            <a:srgbClr val="0F1B2D"/>
+            <a:srgbClr val="161B22"/>
           </a:solidFill>
           <a:ln w="9525">
             <a:solidFill>
-              <a:srgbClr val="58A6FF"/>
+              <a:srgbClr val="30363D"/>
             </a:solidFill>
           </a:ln>
         </p:spPr>
@@ -15083,14 +14614,57 @@
       </p:sp>
       <p:sp>
         <p:nvSpPr>
+          <p:cNvPr id="6" name="Rectangle 5"/>
+          <p:cNvSpPr/>
+          <p:nvPr/>
+        </p:nvSpPr>
+        <p:spPr>
+          <a:xfrm>
+            <a:off x="274320" y="1463040"/>
+            <a:ext cx="3520440" cy="38100"/>
+          </a:xfrm>
+          <a:prstGeom prst="rect">
+            <a:avLst/>
+          </a:prstGeom>
+          <a:solidFill>
+            <a:srgbClr val="58A6FF"/>
+          </a:solidFill>
+          <a:ln>
+            <a:noFill/>
+          </a:ln>
+        </p:spPr>
+        <p:style>
+          <a:lnRef idx="1">
+            <a:schemeClr val="accent1"/>
+          </a:lnRef>
+          <a:fillRef idx="3">
+            <a:schemeClr val="accent1"/>
+          </a:fillRef>
+          <a:effectRef idx="2">
+            <a:schemeClr val="accent1"/>
+          </a:effectRef>
+          <a:fontRef idx="minor">
+            <a:schemeClr val="lt1"/>
+          </a:fontRef>
+        </p:style>
+        <p:txBody>
+          <a:bodyPr rtlCol="0" anchor="ctr"/>
+          <a:lstStyle/>
+          <a:p>
+            <a:pPr algn="ctr"/>
+          </a:p>
+        </p:txBody>
+      </p:sp>
+      <p:sp>
+        <p:nvSpPr>
           <p:cNvPr id="7" name="TextBox 6"/>
           <p:cNvSpPr txBox="1"/>
           <p:nvPr/>
         </p:nvSpPr>
         <p:spPr>
           <a:xfrm>
-            <a:off x="822960" y="1645920"/>
-            <a:ext cx="10515600" cy="365760"/>
+            <a:off x="411480" y="1572768"/>
+            <a:ext cx="3246120" cy="347472"/>
           </a:xfrm>
           <a:prstGeom prst="rect">
             <a:avLst/>
@@ -15105,12 +14679,12 @@
           <a:p>
             <a:pPr algn="l"/>
             <a:r>
-              <a:rPr sz="1400" b="1" i="0">
+              <a:rPr sz="1200" b="1" i="0">
                 <a:solidFill>
                   <a:srgbClr val="E6EDF3"/>
                 </a:solidFill>
               </a:rPr>
-              <a:t>Demo flow</a:t>
+              <a:t>🔍  Hybrid Search (BM25 + Vector)</a:t>
             </a:r>
           </a:p>
         </p:txBody>
@@ -15123,8 +14697,8 @@
         </p:nvSpPr>
         <p:spPr>
           <a:xfrm>
-            <a:off x="822960" y="2103120"/>
-            <a:ext cx="457200" cy="502920"/>
+            <a:off x="411480" y="1965960"/>
+            <a:ext cx="3246120" cy="1645920"/>
           </a:xfrm>
           <a:prstGeom prst="rect">
             <a:avLst/>
@@ -15139,26 +14713,148 @@
           <a:p>
             <a:pPr algn="l"/>
             <a:r>
-              <a:rPr sz="1800" b="0" i="0">
+              <a:rPr sz="1000" b="0" i="0">
+                <a:solidFill>
+                  <a:srgbClr val="8B949E"/>
+                </a:solidFill>
+              </a:rPr>
+              <a:t>pgvector cosine similarity fused with Postgres tsvector BM25 via Reciprocal Rank Fusion (k=60). Dense retrieval catches semantic matches; BM25 catches exact keyword matches. Zero new infrastructure — Postgres handles both. Generated tsv column with GIN index.</a:t>
+            </a:r>
+          </a:p>
+        </p:txBody>
+      </p:sp>
+      <p:sp>
+        <p:nvSpPr>
+          <p:cNvPr id="9" name="Rectangle 8"/>
+          <p:cNvSpPr/>
+          <p:nvPr/>
+        </p:nvSpPr>
+        <p:spPr>
+          <a:xfrm>
+            <a:off x="4069080" y="1463040"/>
+            <a:ext cx="3520440" cy="2286000"/>
+          </a:xfrm>
+          <a:prstGeom prst="rect">
+            <a:avLst/>
+          </a:prstGeom>
+          <a:solidFill>
+            <a:srgbClr val="161B22"/>
+          </a:solidFill>
+          <a:ln w="9525">
+            <a:solidFill>
+              <a:srgbClr val="30363D"/>
+            </a:solidFill>
+          </a:ln>
+        </p:spPr>
+        <p:style>
+          <a:lnRef idx="1">
+            <a:schemeClr val="accent1"/>
+          </a:lnRef>
+          <a:fillRef idx="3">
+            <a:schemeClr val="accent1"/>
+          </a:fillRef>
+          <a:effectRef idx="2">
+            <a:schemeClr val="accent1"/>
+          </a:effectRef>
+          <a:fontRef idx="minor">
+            <a:schemeClr val="lt1"/>
+          </a:fontRef>
+        </p:style>
+        <p:txBody>
+          <a:bodyPr rtlCol="0" anchor="ctr"/>
+          <a:lstStyle/>
+          <a:p>
+            <a:pPr algn="ctr"/>
+          </a:p>
+        </p:txBody>
+      </p:sp>
+      <p:sp>
+        <p:nvSpPr>
+          <p:cNvPr id="10" name="Rectangle 9"/>
+          <p:cNvSpPr/>
+          <p:nvPr/>
+        </p:nvSpPr>
+        <p:spPr>
+          <a:xfrm>
+            <a:off x="4069080" y="1463040"/>
+            <a:ext cx="3520440" cy="38100"/>
+          </a:xfrm>
+          <a:prstGeom prst="rect">
+            <a:avLst/>
+          </a:prstGeom>
+          <a:solidFill>
+            <a:srgbClr val="3FB950"/>
+          </a:solidFill>
+          <a:ln>
+            <a:noFill/>
+          </a:ln>
+        </p:spPr>
+        <p:style>
+          <a:lnRef idx="1">
+            <a:schemeClr val="accent1"/>
+          </a:lnRef>
+          <a:fillRef idx="3">
+            <a:schemeClr val="accent1"/>
+          </a:fillRef>
+          <a:effectRef idx="2">
+            <a:schemeClr val="accent1"/>
+          </a:effectRef>
+          <a:fontRef idx="minor">
+            <a:schemeClr val="lt1"/>
+          </a:fontRef>
+        </p:style>
+        <p:txBody>
+          <a:bodyPr rtlCol="0" anchor="ctr"/>
+          <a:lstStyle/>
+          <a:p>
+            <a:pPr algn="ctr"/>
+          </a:p>
+        </p:txBody>
+      </p:sp>
+      <p:sp>
+        <p:nvSpPr>
+          <p:cNvPr id="11" name="TextBox 10"/>
+          <p:cNvSpPr txBox="1"/>
+          <p:nvPr/>
+        </p:nvSpPr>
+        <p:spPr>
+          <a:xfrm>
+            <a:off x="4206240" y="1572768"/>
+            <a:ext cx="3246120" cy="347472"/>
+          </a:xfrm>
+          <a:prstGeom prst="rect">
+            <a:avLst/>
+          </a:prstGeom>
+          <a:noFill/>
+        </p:spPr>
+        <p:txBody>
+          <a:bodyPr wrap="square">
+            <a:spAutoFit/>
+          </a:bodyPr>
+          <a:lstStyle/>
+          <a:p>
+            <a:pPr algn="l"/>
+            <a:r>
+              <a:rPr sz="1200" b="1" i="0">
                 <a:solidFill>
                   <a:srgbClr val="E6EDF3"/>
                 </a:solidFill>
               </a:rPr>
-              <a:t>1️⃣</a:t>
-            </a:r>
-          </a:p>
-        </p:txBody>
-      </p:sp>
-      <p:sp>
-        <p:nvSpPr>
-          <p:cNvPr id="9" name="TextBox 8"/>
-          <p:cNvSpPr txBox="1"/>
-          <p:nvPr/>
-        </p:nvSpPr>
-        <p:spPr>
-          <a:xfrm>
-            <a:off x="1371600" y="2148840"/>
-            <a:ext cx="10058400" cy="320040"/>
+              <a:t>🔃  Gemini Re-ranking</a:t>
+            </a:r>
+          </a:p>
+        </p:txBody>
+      </p:sp>
+      <p:sp>
+        <p:nvSpPr>
+          <p:cNvPr id="12" name="TextBox 11"/>
+          <p:cNvSpPr txBox="1"/>
+          <p:nvPr/>
+        </p:nvSpPr>
+        <p:spPr>
+          <a:xfrm>
+            <a:off x="4206240" y="1965960"/>
+            <a:ext cx="3246120" cy="1645920"/>
           </a:xfrm>
           <a:prstGeom prst="rect">
             <a:avLst/>
@@ -15173,26 +14869,148 @@
           <a:p>
             <a:pPr algn="l"/>
             <a:r>
-              <a:rPr sz="1300" b="1" i="0">
+              <a:rPr sz="1000" b="0" i="0">
+                <a:solidFill>
+                  <a:srgbClr val="8B949E"/>
+                </a:solidFill>
+              </a:rPr>
+              <a:t>After hybrid retrieval returns k chunks, Gemini ranks them by relevance to the question and keeps the top k/2. Filters out chunks that are semantically close but topically irrelevant before they reach the LLM context window.</a:t>
+            </a:r>
+          </a:p>
+        </p:txBody>
+      </p:sp>
+      <p:sp>
+        <p:nvSpPr>
+          <p:cNvPr id="13" name="Rectangle 12"/>
+          <p:cNvSpPr/>
+          <p:nvPr/>
+        </p:nvSpPr>
+        <p:spPr>
+          <a:xfrm>
+            <a:off x="7863840" y="1463040"/>
+            <a:ext cx="3520440" cy="2286000"/>
+          </a:xfrm>
+          <a:prstGeom prst="rect">
+            <a:avLst/>
+          </a:prstGeom>
+          <a:solidFill>
+            <a:srgbClr val="161B22"/>
+          </a:solidFill>
+          <a:ln w="9525">
+            <a:solidFill>
+              <a:srgbClr val="30363D"/>
+            </a:solidFill>
+          </a:ln>
+        </p:spPr>
+        <p:style>
+          <a:lnRef idx="1">
+            <a:schemeClr val="accent1"/>
+          </a:lnRef>
+          <a:fillRef idx="3">
+            <a:schemeClr val="accent1"/>
+          </a:fillRef>
+          <a:effectRef idx="2">
+            <a:schemeClr val="accent1"/>
+          </a:effectRef>
+          <a:fontRef idx="minor">
+            <a:schemeClr val="lt1"/>
+          </a:fontRef>
+        </p:style>
+        <p:txBody>
+          <a:bodyPr rtlCol="0" anchor="ctr"/>
+          <a:lstStyle/>
+          <a:p>
+            <a:pPr algn="ctr"/>
+          </a:p>
+        </p:txBody>
+      </p:sp>
+      <p:sp>
+        <p:nvSpPr>
+          <p:cNvPr id="14" name="Rectangle 13"/>
+          <p:cNvSpPr/>
+          <p:nvPr/>
+        </p:nvSpPr>
+        <p:spPr>
+          <a:xfrm>
+            <a:off x="7863840" y="1463040"/>
+            <a:ext cx="3520440" cy="38100"/>
+          </a:xfrm>
+          <a:prstGeom prst="rect">
+            <a:avLst/>
+          </a:prstGeom>
+          <a:solidFill>
+            <a:srgbClr val="D2A8FF"/>
+          </a:solidFill>
+          <a:ln>
+            <a:noFill/>
+          </a:ln>
+        </p:spPr>
+        <p:style>
+          <a:lnRef idx="1">
+            <a:schemeClr val="accent1"/>
+          </a:lnRef>
+          <a:fillRef idx="3">
+            <a:schemeClr val="accent1"/>
+          </a:fillRef>
+          <a:effectRef idx="2">
+            <a:schemeClr val="accent1"/>
+          </a:effectRef>
+          <a:fontRef idx="minor">
+            <a:schemeClr val="lt1"/>
+          </a:fontRef>
+        </p:style>
+        <p:txBody>
+          <a:bodyPr rtlCol="0" anchor="ctr"/>
+          <a:lstStyle/>
+          <a:p>
+            <a:pPr algn="ctr"/>
+          </a:p>
+        </p:txBody>
+      </p:sp>
+      <p:sp>
+        <p:nvSpPr>
+          <p:cNvPr id="15" name="TextBox 14"/>
+          <p:cNvSpPr txBox="1"/>
+          <p:nvPr/>
+        </p:nvSpPr>
+        <p:spPr>
+          <a:xfrm>
+            <a:off x="8001000" y="1572768"/>
+            <a:ext cx="3246120" cy="347472"/>
+          </a:xfrm>
+          <a:prstGeom prst="rect">
+            <a:avLst/>
+          </a:prstGeom>
+          <a:noFill/>
+        </p:spPr>
+        <p:txBody>
+          <a:bodyPr wrap="square">
+            <a:spAutoFit/>
+          </a:bodyPr>
+          <a:lstStyle/>
+          <a:p>
+            <a:pPr algn="l"/>
+            <a:r>
+              <a:rPr sz="1200" b="1" i="0">
                 <a:solidFill>
                   <a:srgbClr val="E6EDF3"/>
                 </a:solidFill>
               </a:rPr>
-              <a:t>Upload a PDF</a:t>
-            </a:r>
-          </a:p>
-        </p:txBody>
-      </p:sp>
-      <p:sp>
-        <p:nvSpPr>
-          <p:cNvPr id="10" name="TextBox 9"/>
-          <p:cNvSpPr txBox="1"/>
-          <p:nvPr/>
-        </p:nvSpPr>
-        <p:spPr>
-          <a:xfrm>
-            <a:off x="1371600" y="2450592"/>
-            <a:ext cx="10058400" cy="320040"/>
+              <a:t>🪟  Parent-Child Chunking</a:t>
+            </a:r>
+          </a:p>
+        </p:txBody>
+      </p:sp>
+      <p:sp>
+        <p:nvSpPr>
+          <p:cNvPr id="16" name="TextBox 15"/>
+          <p:cNvSpPr txBox="1"/>
+          <p:nvPr/>
+        </p:nvSpPr>
+        <p:spPr>
+          <a:xfrm>
+            <a:off x="8001000" y="1965960"/>
+            <a:ext cx="3246120" cy="1645920"/>
           </a:xfrm>
           <a:prstGeom prst="rect">
             <a:avLst/>
@@ -15207,26 +15025,114 @@
           <a:p>
             <a:pPr algn="l"/>
             <a:r>
-              <a:rPr sz="1100" b="0" i="0">
+              <a:rPr sz="1000" b="0" i="0">
                 <a:solidFill>
                   <a:srgbClr val="8B949E"/>
                 </a:solidFill>
               </a:rPr>
-              <a:t>Drag &amp; drop onto the sidebar — watch the ingest progress bar: extract → chunk → embed → done</a:t>
-            </a:r>
-          </a:p>
-        </p:txBody>
-      </p:sp>
-      <p:sp>
-        <p:nvSpPr>
-          <p:cNvPr id="11" name="TextBox 10"/>
-          <p:cNvSpPr txBox="1"/>
-          <p:nvPr/>
-        </p:nvSpPr>
-        <p:spPr>
-          <a:xfrm>
-            <a:off x="822960" y="2880360"/>
-            <a:ext cx="457200" cy="502920"/>
+              <a:t>Small chunks (precise retrieval) are embedded and retrieved. Each chunk also stores its adjacent-window text (prev + self + next chunk) as parent_text. The LLM receives the wider context; citations show only the precise matched chunk.</a:t>
+            </a:r>
+          </a:p>
+        </p:txBody>
+      </p:sp>
+      <p:sp>
+        <p:nvSpPr>
+          <p:cNvPr id="17" name="Rectangle 16"/>
+          <p:cNvSpPr/>
+          <p:nvPr/>
+        </p:nvSpPr>
+        <p:spPr>
+          <a:xfrm>
+            <a:off x="2148840" y="3931920"/>
+            <a:ext cx="4114800" cy="2468880"/>
+          </a:xfrm>
+          <a:prstGeom prst="rect">
+            <a:avLst/>
+          </a:prstGeom>
+          <a:solidFill>
+            <a:srgbClr val="161B22"/>
+          </a:solidFill>
+          <a:ln w="9525">
+            <a:solidFill>
+              <a:srgbClr val="30363D"/>
+            </a:solidFill>
+          </a:ln>
+        </p:spPr>
+        <p:style>
+          <a:lnRef idx="1">
+            <a:schemeClr val="accent1"/>
+          </a:lnRef>
+          <a:fillRef idx="3">
+            <a:schemeClr val="accent1"/>
+          </a:fillRef>
+          <a:effectRef idx="2">
+            <a:schemeClr val="accent1"/>
+          </a:effectRef>
+          <a:fontRef idx="minor">
+            <a:schemeClr val="lt1"/>
+          </a:fontRef>
+        </p:style>
+        <p:txBody>
+          <a:bodyPr rtlCol="0" anchor="ctr"/>
+          <a:lstStyle/>
+          <a:p>
+            <a:pPr algn="ctr"/>
+          </a:p>
+        </p:txBody>
+      </p:sp>
+      <p:sp>
+        <p:nvSpPr>
+          <p:cNvPr id="18" name="Rectangle 17"/>
+          <p:cNvSpPr/>
+          <p:nvPr/>
+        </p:nvSpPr>
+        <p:spPr>
+          <a:xfrm>
+            <a:off x="2148840" y="3931920"/>
+            <a:ext cx="4114800" cy="38100"/>
+          </a:xfrm>
+          <a:prstGeom prst="rect">
+            <a:avLst/>
+          </a:prstGeom>
+          <a:solidFill>
+            <a:srgbClr val="F78166"/>
+          </a:solidFill>
+          <a:ln>
+            <a:noFill/>
+          </a:ln>
+        </p:spPr>
+        <p:style>
+          <a:lnRef idx="1">
+            <a:schemeClr val="accent1"/>
+          </a:lnRef>
+          <a:fillRef idx="3">
+            <a:schemeClr val="accent1"/>
+          </a:fillRef>
+          <a:effectRef idx="2">
+            <a:schemeClr val="accent1"/>
+          </a:effectRef>
+          <a:fontRef idx="minor">
+            <a:schemeClr val="lt1"/>
+          </a:fontRef>
+        </p:style>
+        <p:txBody>
+          <a:bodyPr rtlCol="0" anchor="ctr"/>
+          <a:lstStyle/>
+          <a:p>
+            <a:pPr algn="ctr"/>
+          </a:p>
+        </p:txBody>
+      </p:sp>
+      <p:sp>
+        <p:nvSpPr>
+          <p:cNvPr id="19" name="TextBox 18"/>
+          <p:cNvSpPr txBox="1"/>
+          <p:nvPr/>
+        </p:nvSpPr>
+        <p:spPr>
+          <a:xfrm>
+            <a:off x="2286000" y="4041648"/>
+            <a:ext cx="3840480" cy="347472"/>
           </a:xfrm>
           <a:prstGeom prst="rect">
             <a:avLst/>
@@ -15241,26 +15147,26 @@
           <a:p>
             <a:pPr algn="l"/>
             <a:r>
-              <a:rPr sz="1800" b="0" i="0">
+              <a:rPr sz="1200" b="1" i="0">
                 <a:solidFill>
                   <a:srgbClr val="E6EDF3"/>
                 </a:solidFill>
               </a:rPr>
-              <a:t>2️⃣</a:t>
-            </a:r>
-          </a:p>
-        </p:txBody>
-      </p:sp>
-      <p:sp>
-        <p:nvSpPr>
-          <p:cNvPr id="12" name="TextBox 11"/>
-          <p:cNvSpPr txBox="1"/>
-          <p:nvPr/>
-        </p:nvSpPr>
-        <p:spPr>
-          <a:xfrm>
-            <a:off x="1371600" y="2926080"/>
-            <a:ext cx="10058400" cy="320040"/>
+              <a:t>⚡  Duplicate Upload Detection</a:t>
+            </a:r>
+          </a:p>
+        </p:txBody>
+      </p:sp>
+      <p:sp>
+        <p:nvSpPr>
+          <p:cNvPr id="20" name="TextBox 19"/>
+          <p:cNvSpPr txBox="1"/>
+          <p:nvPr/>
+        </p:nvSpPr>
+        <p:spPr>
+          <a:xfrm>
+            <a:off x="2286000" y="4434840"/>
+            <a:ext cx="3840480" cy="1828800"/>
           </a:xfrm>
           <a:prstGeom prst="rect">
             <a:avLst/>
@@ -15275,26 +15181,148 @@
           <a:p>
             <a:pPr algn="l"/>
             <a:r>
-              <a:rPr sz="1300" b="1" i="0">
+              <a:rPr sz="1000" b="0" i="0">
+                <a:solidFill>
+                  <a:srgbClr val="8B949E"/>
+                </a:solidFill>
+              </a:rPr>
+              <a:t>doc_id is a SHA-256 hash of the PDF bytes. On upload, doc_exists() checks doc_meta before extraction begins. Identical file re-uploads skip PyMuPDF, tiktoken, all Gemini embedding calls, and DB writes — instant load from cache.</a:t>
+            </a:r>
+          </a:p>
+        </p:txBody>
+      </p:sp>
+      <p:sp>
+        <p:nvSpPr>
+          <p:cNvPr id="21" name="Rectangle 20"/>
+          <p:cNvSpPr/>
+          <p:nvPr/>
+        </p:nvSpPr>
+        <p:spPr>
+          <a:xfrm>
+            <a:off x="5943600" y="3931920"/>
+            <a:ext cx="4114800" cy="2468880"/>
+          </a:xfrm>
+          <a:prstGeom prst="rect">
+            <a:avLst/>
+          </a:prstGeom>
+          <a:solidFill>
+            <a:srgbClr val="161B22"/>
+          </a:solidFill>
+          <a:ln w="9525">
+            <a:solidFill>
+              <a:srgbClr val="30363D"/>
+            </a:solidFill>
+          </a:ln>
+        </p:spPr>
+        <p:style>
+          <a:lnRef idx="1">
+            <a:schemeClr val="accent1"/>
+          </a:lnRef>
+          <a:fillRef idx="3">
+            <a:schemeClr val="accent1"/>
+          </a:fillRef>
+          <a:effectRef idx="2">
+            <a:schemeClr val="accent1"/>
+          </a:effectRef>
+          <a:fontRef idx="minor">
+            <a:schemeClr val="lt1"/>
+          </a:fontRef>
+        </p:style>
+        <p:txBody>
+          <a:bodyPr rtlCol="0" anchor="ctr"/>
+          <a:lstStyle/>
+          <a:p>
+            <a:pPr algn="ctr"/>
+          </a:p>
+        </p:txBody>
+      </p:sp>
+      <p:sp>
+        <p:nvSpPr>
+          <p:cNvPr id="22" name="Rectangle 21"/>
+          <p:cNvSpPr/>
+          <p:nvPr/>
+        </p:nvSpPr>
+        <p:spPr>
+          <a:xfrm>
+            <a:off x="5943600" y="3931920"/>
+            <a:ext cx="4114800" cy="38100"/>
+          </a:xfrm>
+          <a:prstGeom prst="rect">
+            <a:avLst/>
+          </a:prstGeom>
+          <a:solidFill>
+            <a:srgbClr val="FBBF24"/>
+          </a:solidFill>
+          <a:ln>
+            <a:noFill/>
+          </a:ln>
+        </p:spPr>
+        <p:style>
+          <a:lnRef idx="1">
+            <a:schemeClr val="accent1"/>
+          </a:lnRef>
+          <a:fillRef idx="3">
+            <a:schemeClr val="accent1"/>
+          </a:fillRef>
+          <a:effectRef idx="2">
+            <a:schemeClr val="accent1"/>
+          </a:effectRef>
+          <a:fontRef idx="minor">
+            <a:schemeClr val="lt1"/>
+          </a:fontRef>
+        </p:style>
+        <p:txBody>
+          <a:bodyPr rtlCol="0" anchor="ctr"/>
+          <a:lstStyle/>
+          <a:p>
+            <a:pPr algn="ctr"/>
+          </a:p>
+        </p:txBody>
+      </p:sp>
+      <p:sp>
+        <p:nvSpPr>
+          <p:cNvPr id="23" name="TextBox 22"/>
+          <p:cNvSpPr txBox="1"/>
+          <p:nvPr/>
+        </p:nvSpPr>
+        <p:spPr>
+          <a:xfrm>
+            <a:off x="6080760" y="4041648"/>
+            <a:ext cx="3840480" cy="347472"/>
+          </a:xfrm>
+          <a:prstGeom prst="rect">
+            <a:avLst/>
+          </a:prstGeom>
+          <a:noFill/>
+        </p:spPr>
+        <p:txBody>
+          <a:bodyPr wrap="square">
+            <a:spAutoFit/>
+          </a:bodyPr>
+          <a:lstStyle/>
+          <a:p>
+            <a:pPr algn="l"/>
+            <a:r>
+              <a:rPr sz="1200" b="1" i="0">
                 <a:solidFill>
                   <a:srgbClr val="E6EDF3"/>
                 </a:solidFill>
               </a:rPr>
-              <a:t>Ask a specific question</a:t>
-            </a:r>
-          </a:p>
-        </p:txBody>
-      </p:sp>
-      <p:sp>
-        <p:nvSpPr>
-          <p:cNvPr id="13" name="TextBox 12"/>
-          <p:cNvSpPr txBox="1"/>
-          <p:nvPr/>
-        </p:nvSpPr>
-        <p:spPr>
-          <a:xfrm>
-            <a:off x="1371600" y="3227832"/>
-            <a:ext cx="10058400" cy="320040"/>
+              <a:t>📊  Similarity Score Observability</a:t>
+            </a:r>
+          </a:p>
+        </p:txBody>
+      </p:sp>
+      <p:sp>
+        <p:nvSpPr>
+          <p:cNvPr id="24" name="TextBox 23"/>
+          <p:cNvSpPr txBox="1"/>
+          <p:nvPr/>
+        </p:nvSpPr>
+        <p:spPr>
+          <a:xfrm>
+            <a:off x="6080760" y="4434840"/>
+            <a:ext cx="3840480" cy="1828800"/>
           </a:xfrm>
           <a:prstGeom prst="rect">
             <a:avLst/>
@@ -15309,250 +15337,12 @@
           <a:p>
             <a:pPr algn="l"/>
             <a:r>
-              <a:rPr sz="1100" b="0" i="0">
+              <a:rPr sz="1000" b="0" i="0">
                 <a:solidFill>
                   <a:srgbClr val="8B949E"/>
                 </a:solidFill>
               </a:rPr>
-              <a:t>Something answerable from the document — observe the streamed response and chunk citation pills</a:t>
-            </a:r>
-          </a:p>
-        </p:txBody>
-      </p:sp>
-      <p:sp>
-        <p:nvSpPr>
-          <p:cNvPr id="14" name="TextBox 13"/>
-          <p:cNvSpPr txBox="1"/>
-          <p:nvPr/>
-        </p:nvSpPr>
-        <p:spPr>
-          <a:xfrm>
-            <a:off x="822960" y="3657600"/>
-            <a:ext cx="457200" cy="502920"/>
-          </a:xfrm>
-          <a:prstGeom prst="rect">
-            <a:avLst/>
-          </a:prstGeom>
-          <a:noFill/>
-        </p:spPr>
-        <p:txBody>
-          <a:bodyPr wrap="square">
-            <a:spAutoFit/>
-          </a:bodyPr>
-          <a:lstStyle/>
-          <a:p>
-            <a:pPr algn="l"/>
-            <a:r>
-              <a:rPr sz="1800" b="0" i="0">
-                <a:solidFill>
-                  <a:srgbClr val="E6EDF3"/>
-                </a:solidFill>
-              </a:rPr>
-              <a:t>3️⃣</a:t>
-            </a:r>
-          </a:p>
-        </p:txBody>
-      </p:sp>
-      <p:sp>
-        <p:nvSpPr>
-          <p:cNvPr id="15" name="TextBox 14"/>
-          <p:cNvSpPr txBox="1"/>
-          <p:nvPr/>
-        </p:nvSpPr>
-        <p:spPr>
-          <a:xfrm>
-            <a:off x="1371600" y="3703320"/>
-            <a:ext cx="10058400" cy="320040"/>
-          </a:xfrm>
-          <a:prstGeom prst="rect">
-            <a:avLst/>
-          </a:prstGeom>
-          <a:noFill/>
-        </p:spPr>
-        <p:txBody>
-          <a:bodyPr wrap="square">
-            <a:spAutoFit/>
-          </a:bodyPr>
-          <a:lstStyle/>
-          <a:p>
-            <a:pPr algn="l"/>
-            <a:r>
-              <a:rPr sz="1300" b="1" i="0">
-                <a:solidFill>
-                  <a:srgbClr val="E6EDF3"/>
-                </a:solidFill>
-              </a:rPr>
-              <a:t>Ask something unanswerable</a:t>
-            </a:r>
-          </a:p>
-        </p:txBody>
-      </p:sp>
-      <p:sp>
-        <p:nvSpPr>
-          <p:cNvPr id="16" name="TextBox 15"/>
-          <p:cNvSpPr txBox="1"/>
-          <p:nvPr/>
-        </p:nvSpPr>
-        <p:spPr>
-          <a:xfrm>
-            <a:off x="1371600" y="4005072"/>
-            <a:ext cx="10058400" cy="320040"/>
-          </a:xfrm>
-          <a:prstGeom prst="rect">
-            <a:avLst/>
-          </a:prstGeom>
-          <a:noFill/>
-        </p:spPr>
-        <p:txBody>
-          <a:bodyPr wrap="square">
-            <a:spAutoFit/>
-          </a:bodyPr>
-          <a:lstStyle/>
-          <a:p>
-            <a:pPr algn="l"/>
-            <a:r>
-              <a:rPr sz="1100" b="0" i="0">
-                <a:solidFill>
-                  <a:srgbClr val="8B949E"/>
-                </a:solidFill>
-              </a:rPr>
-              <a:t>Verify the system responds "I don't know." rather than hallucinating</a:t>
-            </a:r>
-          </a:p>
-        </p:txBody>
-      </p:sp>
-      <p:sp>
-        <p:nvSpPr>
-          <p:cNvPr id="17" name="TextBox 16"/>
-          <p:cNvSpPr txBox="1"/>
-          <p:nvPr/>
-        </p:nvSpPr>
-        <p:spPr>
-          <a:xfrm>
-            <a:off x="822960" y="4434840"/>
-            <a:ext cx="457200" cy="502920"/>
-          </a:xfrm>
-          <a:prstGeom prst="rect">
-            <a:avLst/>
-          </a:prstGeom>
-          <a:noFill/>
-        </p:spPr>
-        <p:txBody>
-          <a:bodyPr wrap="square">
-            <a:spAutoFit/>
-          </a:bodyPr>
-          <a:lstStyle/>
-          <a:p>
-            <a:pPr algn="l"/>
-            <a:r>
-              <a:rPr sz="1800" b="0" i="0">
-                <a:solidFill>
-                  <a:srgbClr val="E6EDF3"/>
-                </a:solidFill>
-              </a:rPr>
-              <a:t>4️⃣</a:t>
-            </a:r>
-          </a:p>
-        </p:txBody>
-      </p:sp>
-      <p:sp>
-        <p:nvSpPr>
-          <p:cNvPr id="18" name="TextBox 17"/>
-          <p:cNvSpPr txBox="1"/>
-          <p:nvPr/>
-        </p:nvSpPr>
-        <p:spPr>
-          <a:xfrm>
-            <a:off x="1371600" y="4480560"/>
-            <a:ext cx="10058400" cy="320040"/>
-          </a:xfrm>
-          <a:prstGeom prst="rect">
-            <a:avLst/>
-          </a:prstGeom>
-          <a:noFill/>
-        </p:spPr>
-        <p:txBody>
-          <a:bodyPr wrap="square">
-            <a:spAutoFit/>
-          </a:bodyPr>
-          <a:lstStyle/>
-          <a:p>
-            <a:pPr algn="l"/>
-            <a:r>
-              <a:rPr sz="1300" b="1" i="0">
-                <a:solidFill>
-                  <a:srgbClr val="E6EDF3"/>
-                </a:solidFill>
-              </a:rPr>
-              <a:t>Hover a citation pill</a:t>
-            </a:r>
-          </a:p>
-        </p:txBody>
-      </p:sp>
-      <p:sp>
-        <p:nvSpPr>
-          <p:cNvPr id="19" name="TextBox 18"/>
-          <p:cNvSpPr txBox="1"/>
-          <p:nvPr/>
-        </p:nvSpPr>
-        <p:spPr>
-          <a:xfrm>
-            <a:off x="1371600" y="4782312"/>
-            <a:ext cx="10058400" cy="320040"/>
-          </a:xfrm>
-          <a:prstGeom prst="rect">
-            <a:avLst/>
-          </a:prstGeom>
-          <a:noFill/>
-        </p:spPr>
-        <p:txBody>
-          <a:bodyPr wrap="square">
-            <a:spAutoFit/>
-          </a:bodyPr>
-          <a:lstStyle/>
-          <a:p>
-            <a:pPr algn="l"/>
-            <a:r>
-              <a:rPr sz="1100" b="0" i="0">
-                <a:solidFill>
-                  <a:srgbClr val="8B949E"/>
-                </a:solidFill>
-              </a:rPr>
-              <a:t>See the raw chunk text that grounded the answer</a:t>
-            </a:r>
-          </a:p>
-        </p:txBody>
-      </p:sp>
-      <p:sp>
-        <p:nvSpPr>
-          <p:cNvPr id="20" name="TextBox 19"/>
-          <p:cNvSpPr txBox="1"/>
-          <p:nvPr/>
-        </p:nvSpPr>
-        <p:spPr>
-          <a:xfrm>
-            <a:off x="548640" y="5760720"/>
-            <a:ext cx="11091672" cy="365760"/>
-          </a:xfrm>
-          <a:prstGeom prst="rect">
-            <a:avLst/>
-          </a:prstGeom>
-          <a:noFill/>
-        </p:spPr>
-        <p:txBody>
-          <a:bodyPr wrap="square">
-            <a:spAutoFit/>
-          </a:bodyPr>
-          <a:lstStyle/>
-          <a:p>
-            <a:pPr algn="ctr"/>
-            <a:r>
-              <a:rPr sz="1100" b="0" i="0">
-                <a:solidFill>
-                  <a:srgbClr val="8B949E"/>
-                </a:solidFill>
-              </a:rPr>
-              <a:t>http://localhost:8000   ·   docker compose up -d &amp;&amp; uvicorn backend.main:app --reload</a:t>
+              <a:t>Every query logs avg and min cosine similarity across retrieved chunks — a low min_sim signals k is too small for the document. Citation pills in the UI show a colour-coded % badge: green ≥75%, amber ≥50%, red &lt;50%.</a:t>
             </a:r>
           </a:p>
         </p:txBody>

</xml_diff>